<commit_message>
feat(presentation): organize slide assets and embed live hyperlinks on slide 6 references
</commit_message>
<xml_diff>
--- a/SIH2026-IDEA-Presentation-Format.pptx
+++ b/SIH2026-IDEA-Presentation-Format.pptx
@@ -10065,40 +10065,6 @@
       </p:sp>
       <p:sp>
         <p:nvSpPr>
-          <p:cNvPr id="17409" name="Title 1"/>
-          <p:cNvSpPr>
-            <a:spLocks noGrp="1"/>
-          </p:cNvSpPr>
-          <p:nvPr>
-            <p:ph type="title"/>
-          </p:nvPr>
-        </p:nvSpPr>
-        <p:spPr>
-          <a:xfrm>
-            <a:off x="1645920" y="109728"/>
-            <a:ext cx="8046720" cy="914400"/>
-          </a:xfrm>
-        </p:spPr>
-        <p:txBody>
-          <a:bodyPr/>
-          <a:lstStyle/>
-          <a:p>
-            <a:pPr eaLnBrk="1" hangingPunct="1" algn="ctr">
-              <a:defRPr sz="1800" b="1">
-                <a:solidFill>
-                  <a:srgbClr val="000000"/>
-                </a:solidFill>
-                <a:latin typeface="Times New Roman"/>
-              </a:defRPr>
-            </a:pPr>
-            <a:r>
-              <a:t>RESEARCH AND REFERENCES</a:t>
-            </a:r>
-          </a:p>
-        </p:txBody>
-      </p:sp>
-      <p:sp>
-        <p:nvSpPr>
           <p:cNvPr id="6" name="Slide Number Placeholder 5"/>
           <p:cNvSpPr>
             <a:spLocks noGrp="1"/>
@@ -10251,86 +10217,24 @@
           </a:p>
         </p:txBody>
       </p:sp>
-      <p:sp>
-        <p:nvSpPr>
-          <p:cNvPr id="9" name="Oval 8" descr="Your startup LOGO">
-            <a:extLst>
-              <a:ext uri="{FF2B5EF4-FFF2-40B4-BE49-F238E27FC236}">
-                <a16:creationId xmlns:a16="http://schemas.microsoft.com/office/drawing/2014/main" id="{5DBCE864-823D-4A13-9607-5DA1F0ED5FB8}"/>
-              </a:ext>
-              <a:ext uri="{C183D7F6-B498-43B3-948B-1728B52AA6E4}">
-                <adec:decorative xmlns:adec="http://schemas.microsoft.com/office/drawing/2017/decorative" xmlns="" val="0"/>
-              </a:ext>
-            </a:extLst>
-          </p:cNvPr>
-          <p:cNvSpPr/>
-          <p:nvPr/>
-        </p:nvSpPr>
-        <p:spPr>
-          <a:xfrm>
-            <a:off x="329773" y="252246"/>
-            <a:ext cx="1251857" cy="807334"/>
-          </a:xfrm>
-          <a:prstGeom prst="ellipse">
-            <a:avLst/>
-          </a:prstGeom>
-        </p:spPr>
-        <p:style>
-          <a:lnRef idx="2">
-            <a:schemeClr val="accent4"/>
-          </a:lnRef>
-          <a:fillRef idx="1">
-            <a:schemeClr val="lt1"/>
-          </a:fillRef>
-          <a:effectRef idx="0">
-            <a:schemeClr val="accent4"/>
-          </a:effectRef>
-          <a:fontRef idx="minor">
-            <a:schemeClr val="dk1"/>
-          </a:fontRef>
-        </p:style>
-        <p:txBody>
-          <a:bodyPr rtlCol="0" anchor="ctr"/>
-          <a:lstStyle/>
-          <a:p>
-            <a:pPr algn="ctr">
-              <a:defRPr sz="1400" b="1">
-                <a:solidFill>
-                  <a:srgbClr val="000000"/>
-                </a:solidFill>
-                <a:latin typeface="Arial"/>
-              </a:defRPr>
-            </a:pPr>
-            <a:r>
-              <a:t>Thinkers</a:t>
-            </a:r>
-          </a:p>
-        </p:txBody>
-      </p:sp>
       <p:pic>
         <p:nvPicPr>
-          <p:cNvPr id="12" name="Picture 11"/>
+          <p:cNvPr id="11" name="Picture 10" descr="pyrosat_slide6_references_filled.png"/>
           <p:cNvPicPr>
             <a:picLocks noChangeAspect="1"/>
           </p:cNvPicPr>
           <p:nvPr/>
         </p:nvPicPr>
         <p:blipFill>
-          <a:blip r:embed="rId3">
-            <a:extLst>
-              <a:ext uri="{28A0092B-C50C-407E-A947-70E740481C1C}">
-                <a14:useLocalDpi xmlns:a14="http://schemas.microsoft.com/office/drawing/2010/main" val="0"/>
-              </a:ext>
-            </a:extLst>
-          </a:blip>
+          <a:blip r:embed="rId4"/>
           <a:stretch>
             <a:fillRect/>
           </a:stretch>
         </p:blipFill>
         <p:spPr>
           <a:xfrm>
-            <a:off x="9780086" y="1500"/>
-            <a:ext cx="2249850" cy="1062337"/>
+            <a:off x="0" y="0"/>
+            <a:ext cx="12191695" cy="6858000"/>
           </a:xfrm>
           <a:prstGeom prst="rect">
             <a:avLst/>
@@ -10339,7 +10243,43 @@
       </p:pic>
       <p:sp>
         <p:nvSpPr>
-          <p:cNvPr id="17410" name="Rectangle 17409"/>
+          <p:cNvPr id="12" name="TextBox 11"/>
+          <p:cNvSpPr txBox="1"/>
+          <p:nvPr/>
+        </p:nvSpPr>
+        <p:spPr>
+          <a:xfrm>
+            <a:off x="1645920" y="109728"/>
+            <a:ext cx="8046720" cy="914400"/>
+          </a:xfrm>
+          <a:prstGeom prst="rect">
+            <a:avLst/>
+          </a:prstGeom>
+          <a:noFill/>
+        </p:spPr>
+        <p:txBody>
+          <a:bodyPr wrap="square">
+            <a:spAutoFit/>
+          </a:bodyPr>
+          <a:lstStyle/>
+          <a:p>
+            <a:pPr algn="ctr">
+              <a:defRPr sz="1800" b="1">
+                <a:solidFill>
+                  <a:srgbClr val="000000"/>
+                </a:solidFill>
+                <a:latin typeface="Times New Roman"/>
+              </a:defRPr>
+            </a:pPr>
+            <a:r>
+              <a:t>RESEARCH AND REFERENCES</a:t>
+            </a:r>
+          </a:p>
+        </p:txBody>
+      </p:sp>
+      <p:sp>
+        <p:nvSpPr>
+          <p:cNvPr id="13" name="Rectangle 12"/>
           <p:cNvSpPr/>
           <p:nvPr/>
         </p:nvSpPr>
@@ -10380,22 +10320,515 @@
           </a:p>
         </p:txBody>
       </p:sp>
-      <p:sp>
-        <p:nvSpPr>
-          <p:cNvPr id="17411" name="Rectangle 17410"/>
+      <p:pic>
+        <p:nvPicPr>
+          <p:cNvPr id="14" name="Picture 13" descr="image.png"/>
+          <p:cNvPicPr>
+            <a:picLocks noChangeAspect="1"/>
+          </p:cNvPicPr>
+          <p:nvPr/>
+        </p:nvPicPr>
+        <p:blipFill>
+          <a:blip r:embed="rId5"/>
+          <a:stretch>
+            <a:fillRect/>
+          </a:stretch>
+        </p:blipFill>
+        <p:spPr>
+          <a:xfrm>
+            <a:off x="347472" y="1353312"/>
+            <a:ext cx="11484864" cy="1920240"/>
+          </a:xfrm>
+          <a:prstGeom prst="rect">
+            <a:avLst/>
+          </a:prstGeom>
+        </p:spPr>
+      </p:pic>
+      <p:sp>
+        <p:nvSpPr>
+          <p:cNvPr id="15" name="TextBox 14"/>
+          <p:cNvSpPr txBox="1"/>
+          <p:nvPr/>
+        </p:nvSpPr>
+        <p:spPr>
+          <a:xfrm>
+            <a:off x="438912" y="1993392"/>
+            <a:ext cx="1444752" cy="1243584"/>
+          </a:xfrm>
+          <a:prstGeom prst="rect">
+            <a:avLst/>
+          </a:prstGeom>
+          <a:noFill/>
+        </p:spPr>
+        <p:txBody>
+          <a:bodyPr wrap="square" lIns="0" rIns="0" tIns="0" bIns="0">
+            <a:spAutoFit/>
+          </a:bodyPr>
+          <a:lstStyle/>
+          <a:p>
+            <a:pPr algn="ctr">
+              <a:spcAft>
+                <a:spcPts val="300"/>
+              </a:spcAft>
+            </a:pPr>
+            <a:r>
+              <a:rPr sz="950" b="1" u="sng">
+                <a:solidFill>
+                  <a:srgbClr val="0E4BA0"/>
+                </a:solidFill>
+                <a:latin typeface="Arial"/>
+                <a:hlinkClick r:id="rId9"/>
+              </a:rPr>
+              <a:t>NASA FIRMS
+</a:t>
+            </a:r>
+            <a:r>
+              <a:rPr sz="950" b="1" u="sng">
+                <a:solidFill>
+                  <a:srgbClr val="0E4BA0"/>
+                </a:solidFill>
+                <a:latin typeface="Arial"/>
+                <a:hlinkClick r:id="rId9"/>
+              </a:rPr>
+              <a:t>Telemetry</a:t>
+            </a:r>
+          </a:p>
+          <a:p>
+            <a:pPr algn="ctr">
+              <a:spcBef>
+                <a:spcPts val="200"/>
+              </a:spcBef>
+              <a:defRPr sz="750">
+                <a:solidFill>
+                  <a:srgbClr val="282D37"/>
+                </a:solidFill>
+                <a:latin typeface="Arial"/>
+              </a:defRPr>
+            </a:pPr>
+            <a:r>
+              <a:t>NRT Thermal Hotspot Ingestion — VIIRS 375m &amp; MODIS 1km active fire feeds.</a:t>
+            </a:r>
+          </a:p>
+        </p:txBody>
+      </p:sp>
+      <p:sp>
+        <p:nvSpPr>
+          <p:cNvPr id="16" name="TextBox 15"/>
+          <p:cNvSpPr txBox="1"/>
+          <p:nvPr/>
+        </p:nvSpPr>
+        <p:spPr>
+          <a:xfrm>
+            <a:off x="2079606" y="1993392"/>
+            <a:ext cx="1444752" cy="1243584"/>
+          </a:xfrm>
+          <a:prstGeom prst="rect">
+            <a:avLst/>
+          </a:prstGeom>
+          <a:noFill/>
+        </p:spPr>
+        <p:txBody>
+          <a:bodyPr wrap="square" lIns="0" rIns="0" tIns="0" bIns="0">
+            <a:spAutoFit/>
+          </a:bodyPr>
+          <a:lstStyle/>
+          <a:p>
+            <a:pPr algn="ctr">
+              <a:spcAft>
+                <a:spcPts val="300"/>
+              </a:spcAft>
+            </a:pPr>
+            <a:r>
+              <a:rPr sz="950" b="1" u="sng">
+                <a:solidFill>
+                  <a:srgbClr val="0E4BA0"/>
+                </a:solidFill>
+                <a:latin typeface="Arial"/>
+                <a:hlinkClick r:id="rId10"/>
+              </a:rPr>
+              <a:t>Dozier Pyrometry
+</a:t>
+            </a:r>
+            <a:r>
+              <a:rPr sz="950" b="1" u="sng">
+                <a:solidFill>
+                  <a:srgbClr val="0E4BA0"/>
+                </a:solidFill>
+                <a:latin typeface="Arial"/>
+                <a:hlinkClick r:id="rId10"/>
+              </a:rPr>
+              <a:t>(1981)</a:t>
+            </a:r>
+          </a:p>
+          <a:p>
+            <a:pPr algn="ctr">
+              <a:spcBef>
+                <a:spcPts val="200"/>
+              </a:spcBef>
+              <a:defRPr sz="750">
+                <a:solidFill>
+                  <a:srgbClr val="282D37"/>
+                </a:solidFill>
+                <a:latin typeface="Arial"/>
+              </a:defRPr>
+            </a:pPr>
+            <a:r>
+              <a:t>Sub-Pixel Planck Inversion — Resolves flame temp (Tf &gt; 1100 K) &amp; sub-pixel area (Af).</a:t>
+            </a:r>
+          </a:p>
+        </p:txBody>
+      </p:sp>
+      <p:sp>
+        <p:nvSpPr>
+          <p:cNvPr id="17" name="TextBox 16"/>
+          <p:cNvSpPr txBox="1"/>
+          <p:nvPr/>
+        </p:nvSpPr>
+        <p:spPr>
+          <a:xfrm>
+            <a:off x="3720301" y="1993392"/>
+            <a:ext cx="1444752" cy="1243584"/>
+          </a:xfrm>
+          <a:prstGeom prst="rect">
+            <a:avLst/>
+          </a:prstGeom>
+          <a:noFill/>
+        </p:spPr>
+        <p:txBody>
+          <a:bodyPr wrap="square" lIns="0" rIns="0" tIns="0" bIns="0">
+            <a:spAutoFit/>
+          </a:bodyPr>
+          <a:lstStyle/>
+          <a:p>
+            <a:pPr algn="ctr">
+              <a:spcAft>
+                <a:spcPts val="300"/>
+              </a:spcAft>
+            </a:pPr>
+            <a:r>
+              <a:rPr sz="950" b="1" u="sng">
+                <a:solidFill>
+                  <a:srgbClr val="0E4BA0"/>
+                </a:solidFill>
+                <a:latin typeface="Arial"/>
+                <a:hlinkClick r:id="rId11"/>
+              </a:rPr>
+              <a:t>ESA WorldCover
+</a:t>
+            </a:r>
+            <a:r>
+              <a:rPr sz="950" b="1" u="sng">
+                <a:solidFill>
+                  <a:srgbClr val="0E4BA0"/>
+                </a:solidFill>
+                <a:latin typeface="Arial"/>
+                <a:hlinkClick r:id="rId11"/>
+              </a:rPr>
+              <a:t>10m</a:t>
+            </a:r>
+          </a:p>
+          <a:p>
+            <a:pPr algn="ctr">
+              <a:spcBef>
+                <a:spcPts val="200"/>
+              </a:spcBef>
+              <a:defRPr sz="750">
+                <a:solidFill>
+                  <a:srgbClr val="282D37"/>
+                </a:solidFill>
+                <a:latin typeface="Arial"/>
+              </a:defRPr>
+            </a:pPr>
+            <a:r>
+              <a:t>10m Surface Ground Truth — Sentinel-1/2 LULC classifying Built-up (Class 50) vs Cropland.</a:t>
+            </a:r>
+          </a:p>
+        </p:txBody>
+      </p:sp>
+      <p:sp>
+        <p:nvSpPr>
+          <p:cNvPr id="18" name="TextBox 17"/>
+          <p:cNvSpPr txBox="1"/>
+          <p:nvPr/>
+        </p:nvSpPr>
+        <p:spPr>
+          <a:xfrm>
+            <a:off x="5360996" y="1993392"/>
+            <a:ext cx="1444752" cy="1243584"/>
+          </a:xfrm>
+          <a:prstGeom prst="rect">
+            <a:avLst/>
+          </a:prstGeom>
+          <a:noFill/>
+        </p:spPr>
+        <p:txBody>
+          <a:bodyPr wrap="square" lIns="0" rIns="0" tIns="0" bIns="0">
+            <a:spAutoFit/>
+          </a:bodyPr>
+          <a:lstStyle/>
+          <a:p>
+            <a:pPr algn="ctr">
+              <a:spcAft>
+                <a:spcPts val="300"/>
+              </a:spcAft>
+            </a:pPr>
+            <a:r>
+              <a:rPr sz="950" b="1" u="sng">
+                <a:solidFill>
+                  <a:srgbClr val="0E4BA0"/>
+                </a:solidFill>
+                <a:latin typeface="Arial"/>
+                <a:hlinkClick r:id="rId12"/>
+              </a:rPr>
+              <a:t>GEM &amp; World Bank
+</a:t>
+            </a:r>
+            <a:r>
+              <a:rPr sz="950" b="1" u="sng">
+                <a:solidFill>
+                  <a:srgbClr val="0E4BA0"/>
+                </a:solidFill>
+                <a:latin typeface="Arial"/>
+                <a:hlinkClick r:id="rId12"/>
+              </a:rPr>
+              <a:t>GGFR</a:t>
+            </a:r>
+          </a:p>
+          <a:p>
+            <a:pPr algn="ctr">
+              <a:spcBef>
+                <a:spcPts val="200"/>
+              </a:spcBef>
+              <a:defRPr sz="750">
+                <a:solidFill>
+                  <a:srgbClr val="282D37"/>
+                </a:solidFill>
+                <a:latin typeface="Arial"/>
+              </a:defRPr>
+            </a:pPr>
+            <a:r>
+              <a:t>2,000+ Facility Registry — Catalog of Indian refineries, petrochemical hubs &amp; flaring stacks.</a:t>
+            </a:r>
+          </a:p>
+        </p:txBody>
+      </p:sp>
+      <p:sp>
+        <p:nvSpPr>
+          <p:cNvPr id="19" name="TextBox 18"/>
+          <p:cNvSpPr txBox="1"/>
+          <p:nvPr/>
+        </p:nvSpPr>
+        <p:spPr>
+          <a:xfrm>
+            <a:off x="7001691" y="1993392"/>
+            <a:ext cx="1444752" cy="1243584"/>
+          </a:xfrm>
+          <a:prstGeom prst="rect">
+            <a:avLst/>
+          </a:prstGeom>
+          <a:noFill/>
+        </p:spPr>
+        <p:txBody>
+          <a:bodyPr wrap="square" lIns="0" rIns="0" tIns="0" bIns="0">
+            <a:spAutoFit/>
+          </a:bodyPr>
+          <a:lstStyle/>
+          <a:p>
+            <a:pPr algn="ctr">
+              <a:spcAft>
+                <a:spcPts val="300"/>
+              </a:spcAft>
+            </a:pPr>
+            <a:r>
+              <a:rPr sz="950" b="1" u="sng">
+                <a:solidFill>
+                  <a:srgbClr val="0E4BA0"/>
+                </a:solidFill>
+                <a:latin typeface="Arial"/>
+                <a:hlinkClick r:id="rId13"/>
+              </a:rPr>
+              <a:t>NOAA CAMEO &amp;
+</a:t>
+            </a:r>
+            <a:r>
+              <a:rPr sz="950" b="1" u="sng">
+                <a:solidFill>
+                  <a:srgbClr val="0E4BA0"/>
+                </a:solidFill>
+                <a:latin typeface="Arial"/>
+                <a:hlinkClick r:id="rId13"/>
+              </a:rPr>
+              <a:t>NIOSH</a:t>
+            </a:r>
+          </a:p>
+          <a:p>
+            <a:pPr algn="ctr">
+              <a:spcBef>
+                <a:spcPts val="200"/>
+              </a:spcBef>
+              <a:defRPr sz="750">
+                <a:solidFill>
+                  <a:srgbClr val="282D37"/>
+                </a:solidFill>
+                <a:latin typeface="Arial"/>
+              </a:defRPr>
+            </a:pPr>
+            <a:r>
+              <a:t>Chemical &amp; HazMat Profiles — Reactivity data, UN placards &amp; toxic thresholds.</a:t>
+            </a:r>
+          </a:p>
+        </p:txBody>
+      </p:sp>
+      <p:sp>
+        <p:nvSpPr>
+          <p:cNvPr id="20" name="TextBox 19"/>
+          <p:cNvSpPr txBox="1"/>
+          <p:nvPr/>
+        </p:nvSpPr>
+        <p:spPr>
+          <a:xfrm>
+            <a:off x="8642386" y="1993392"/>
+            <a:ext cx="1444752" cy="1243584"/>
+          </a:xfrm>
+          <a:prstGeom prst="rect">
+            <a:avLst/>
+          </a:prstGeom>
+          <a:noFill/>
+        </p:spPr>
+        <p:txBody>
+          <a:bodyPr wrap="square" lIns="0" rIns="0" tIns="0" bIns="0">
+            <a:spAutoFit/>
+          </a:bodyPr>
+          <a:lstStyle/>
+          <a:p>
+            <a:pPr algn="ctr">
+              <a:spcAft>
+                <a:spcPts val="300"/>
+              </a:spcAft>
+            </a:pPr>
+            <a:r>
+              <a:rPr sz="950" b="1" u="sng">
+                <a:solidFill>
+                  <a:srgbClr val="0E4BA0"/>
+                </a:solidFill>
+                <a:latin typeface="Arial"/>
+                <a:hlinkClick r:id="rId14"/>
+              </a:rPr>
+              <a:t>EPA / Briggs
+</a:t>
+            </a:r>
+            <a:r>
+              <a:rPr sz="950" b="1" u="sng">
+                <a:solidFill>
+                  <a:srgbClr val="0E4BA0"/>
+                </a:solidFill>
+                <a:latin typeface="Arial"/>
+                <a:hlinkClick r:id="rId14"/>
+              </a:rPr>
+              <a:t>Plume Rise</a:t>
+            </a:r>
+          </a:p>
+          <a:p>
+            <a:pPr algn="ctr">
+              <a:spcBef>
+                <a:spcPts val="200"/>
+              </a:spcBef>
+              <a:defRPr sz="750">
+                <a:solidFill>
+                  <a:srgbClr val="282D37"/>
+                </a:solidFill>
+                <a:latin typeface="Arial"/>
+              </a:defRPr>
+            </a:pPr>
+            <a:r>
+              <a:t>Atmospheric Dispersion — Buoyant plume rise &amp; Pasquill-Gifford Gaussian dispersion.</a:t>
+            </a:r>
+          </a:p>
+        </p:txBody>
+      </p:sp>
+      <p:sp>
+        <p:nvSpPr>
+          <p:cNvPr id="21" name="TextBox 20"/>
+          <p:cNvSpPr txBox="1"/>
+          <p:nvPr/>
+        </p:nvSpPr>
+        <p:spPr>
+          <a:xfrm>
+            <a:off x="10283081" y="1993392"/>
+            <a:ext cx="1444752" cy="1243584"/>
+          </a:xfrm>
+          <a:prstGeom prst="rect">
+            <a:avLst/>
+          </a:prstGeom>
+          <a:noFill/>
+        </p:spPr>
+        <p:txBody>
+          <a:bodyPr wrap="square" lIns="0" rIns="0" tIns="0" bIns="0">
+            <a:spAutoFit/>
+          </a:bodyPr>
+          <a:lstStyle/>
+          <a:p>
+            <a:pPr algn="ctr">
+              <a:spcAft>
+                <a:spcPts val="300"/>
+              </a:spcAft>
+            </a:pPr>
+            <a:r>
+              <a:rPr sz="950" b="1" u="sng">
+                <a:solidFill>
+                  <a:srgbClr val="0E4BA0"/>
+                </a:solidFill>
+                <a:latin typeface="Arial"/>
+                <a:hlinkClick r:id="rId15"/>
+              </a:rPr>
+              <a:t>NDRF &amp; HazMat
+</a:t>
+            </a:r>
+            <a:r>
+              <a:rPr sz="950" b="1" u="sng">
+                <a:solidFill>
+                  <a:srgbClr val="0E4BA0"/>
+                </a:solidFill>
+                <a:latin typeface="Arial"/>
+                <a:hlinkClick r:id="rId15"/>
+              </a:rPr>
+              <a:t>ERG</a:t>
+            </a:r>
+          </a:p>
+          <a:p>
+            <a:pPr algn="ctr">
+              <a:spcBef>
+                <a:spcPts val="200"/>
+              </a:spcBef>
+              <a:defRPr sz="750">
+                <a:solidFill>
+                  <a:srgbClr val="282D37"/>
+                </a:solidFill>
+                <a:latin typeface="Arial"/>
+              </a:defRPr>
+            </a:pPr>
+            <a:r>
+              <a:t>Tactical Standoff &amp; Routing — Emergency chemical standoff, isolation corridors &amp; automated dispatch.</a:t>
+            </a:r>
+          </a:p>
+        </p:txBody>
+      </p:sp>
+      <p:sp>
+        <p:nvSpPr>
+          <p:cNvPr id="22" name="Rectangle 21"/>
           <p:cNvSpPr/>
           <p:nvPr/>
         </p:nvSpPr>
         <p:spPr>
           <a:xfrm>
-            <a:off x="5440680" y="1115568"/>
-            <a:ext cx="13716" cy="4983480"/>
+            <a:off x="347472" y="3401568"/>
+            <a:ext cx="10241280" cy="13716"/>
           </a:xfrm>
           <a:prstGeom prst="rect">
             <a:avLst/>
           </a:prstGeom>
           <a:solidFill>
-            <a:srgbClr val="B9C3CD"/>
+            <a:srgbClr val="CBD5E1"/>
           </a:solidFill>
           <a:ln>
             <a:noFill/>
@@ -10425,14 +10858,14 @@
       </p:sp>
       <p:sp>
         <p:nvSpPr>
-          <p:cNvPr id="17412" name="TextBox 17411"/>
+          <p:cNvPr id="23" name="TextBox 22"/>
           <p:cNvSpPr txBox="1"/>
           <p:nvPr/>
         </p:nvSpPr>
         <p:spPr>
           <a:xfrm>
-            <a:off x="347472" y="1133856"/>
-            <a:ext cx="4983480" cy="4983480"/>
+            <a:off x="10744200" y="3218688"/>
+            <a:ext cx="1097280" cy="320040"/>
           </a:xfrm>
           <a:prstGeom prst="rect">
             <a:avLst/>
@@ -10440,223 +10873,59 @@
           <a:noFill/>
         </p:spPr>
         <p:txBody>
-          <a:bodyPr wrap="square" lIns="0" rIns="0" tIns="0" bIns="0">
+          <a:bodyPr wrap="none" lIns="0" rIns="0" tIns="0" bIns="0">
             <a:spAutoFit/>
           </a:bodyPr>
           <a:lstStyle/>
           <a:p>
             <a:pPr>
-              <a:spcAft>
-                <a:spcPts val="400"/>
-              </a:spcAft>
-              <a:defRPr sz="1250" b="1" u="sng">
-                <a:solidFill>
-                  <a:srgbClr val="2B5B84"/>
+              <a:defRPr sz="1500" b="1">
+                <a:solidFill>
+                  <a:srgbClr val="94A3B8"/>
                 </a:solidFill>
                 <a:latin typeface="Arial"/>
               </a:defRPr>
             </a:pPr>
             <a:r>
-              <a:t>Research &amp; Scientific Literature:</a:t>
-            </a:r>
-          </a:p>
-          <a:p>
-            <a:pPr>
-              <a:lnSpc>
-                <a:spcPct val="115000"/>
-              </a:lnSpc>
-              <a:spcAft>
-                <a:spcPts val="600"/>
-              </a:spcAft>
-            </a:pPr>
-            <a:r>
-              <a:rPr sz="900">
-                <a:solidFill>
-                  <a:srgbClr val="1E1E1E"/>
-                </a:solidFill>
-                <a:latin typeface="Arial"/>
-              </a:rPr>
-              <a:t>• </a:t>
-            </a:r>
-            <a:r>
-              <a:rPr sz="900" b="1">
-                <a:solidFill>
-                  <a:srgbClr val="000000"/>
-                </a:solidFill>
-                <a:latin typeface="Arial"/>
-              </a:rPr>
-              <a:t>Dozier, J. (1981): </a:t>
-            </a:r>
-            <a:r>
-              <a:rPr sz="900">
-                <a:solidFill>
-                  <a:srgbClr val="1E1E1E"/>
-                </a:solidFill>
-                <a:latin typeface="Arial"/>
-              </a:rPr>
-              <a:t>"A method for satellite identification of surface temperature fields of subpixel resolving scale." Remote Sensing of Environment, 11(1), 221-229. [Physical basis for sub-pixel Planck inversion]</a:t>
-            </a:r>
-          </a:p>
-          <a:p>
-            <a:pPr>
-              <a:lnSpc>
-                <a:spcPct val="115000"/>
-              </a:lnSpc>
-              <a:spcAft>
-                <a:spcPts val="600"/>
-              </a:spcAft>
-            </a:pPr>
-            <a:r>
-              <a:rPr sz="900">
-                <a:solidFill>
-                  <a:srgbClr val="1E1E1E"/>
-                </a:solidFill>
-                <a:latin typeface="Arial"/>
-              </a:rPr>
-              <a:t>• </a:t>
-            </a:r>
-            <a:r>
-              <a:rPr sz="900" b="1">
-                <a:solidFill>
-                  <a:srgbClr val="000000"/>
-                </a:solidFill>
-                <a:latin typeface="Arial"/>
-              </a:rPr>
-              <a:t>Lundberg, S. M., &amp; Lee, S.-I. (2017): </a:t>
-            </a:r>
-            <a:r>
-              <a:rPr sz="900">
-                <a:solidFill>
-                  <a:srgbClr val="1E1E1E"/>
-                </a:solidFill>
-                <a:latin typeface="Arial"/>
-              </a:rPr>
-              <a:t>"A Unified Approach to Interpreting Model Predictions." NeurIPS 30. [Exact polynomial TreeSHAP dynamic programming algorithm]</a:t>
-            </a:r>
-          </a:p>
-          <a:p>
-            <a:pPr>
-              <a:lnSpc>
-                <a:spcPct val="115000"/>
-              </a:lnSpc>
-              <a:spcAft>
-                <a:spcPts val="600"/>
-              </a:spcAft>
-            </a:pPr>
-            <a:r>
-              <a:rPr sz="900">
-                <a:solidFill>
-                  <a:srgbClr val="1E1E1E"/>
-                </a:solidFill>
-                <a:latin typeface="Arial"/>
-              </a:rPr>
-              <a:t>• </a:t>
-            </a:r>
-            <a:r>
-              <a:rPr sz="900" b="1">
-                <a:solidFill>
-                  <a:srgbClr val="000000"/>
-                </a:solidFill>
-                <a:latin typeface="Arial"/>
-              </a:rPr>
-              <a:t>Pasquill, F. (1961) &amp; Briggs, G. A. (1975): </a:t>
-            </a:r>
-            <a:r>
-              <a:rPr sz="900">
-                <a:solidFill>
-                  <a:srgbClr val="1E1E1E"/>
-                </a:solidFill>
-                <a:latin typeface="Arial"/>
-              </a:rPr>
-              <a:t>"Atmospheric Diffusion &amp; Plume Rise Predictions." US Atomic Energy Commission. [Gaussian dispersion &amp; buoyant plume model]</a:t>
-            </a:r>
-          </a:p>
-          <a:p>
-            <a:pPr>
-              <a:lnSpc>
-                <a:spcPct val="115000"/>
-              </a:lnSpc>
-              <a:spcAft>
-                <a:spcPts val="600"/>
-              </a:spcAft>
-            </a:pPr>
-            <a:r>
-              <a:rPr sz="900">
-                <a:solidFill>
-                  <a:srgbClr val="1E1E1E"/>
-                </a:solidFill>
-                <a:latin typeface="Arial"/>
-              </a:rPr>
-              <a:t>• </a:t>
-            </a:r>
-            <a:r>
-              <a:rPr sz="900" b="1">
-                <a:solidFill>
-                  <a:srgbClr val="000000"/>
-                </a:solidFill>
-                <a:latin typeface="Arial"/>
-              </a:rPr>
-              <a:t>Giglio, L., et al. (2016): </a:t>
-            </a:r>
-            <a:r>
-              <a:rPr sz="900">
-                <a:solidFill>
-                  <a:srgbClr val="1E1E1E"/>
-                </a:solidFill>
-                <a:latin typeface="Arial"/>
-              </a:rPr>
-              <a:t>"The Collection 6 MODIS active fire detection algorithm and fire products." Remote Sensing of Environment, 178, 31-41.</a:t>
-            </a:r>
-          </a:p>
-          <a:p>
-            <a:pPr>
-              <a:lnSpc>
-                <a:spcPct val="115000"/>
-              </a:lnSpc>
-              <a:spcAft>
-                <a:spcPts val="600"/>
-              </a:spcAft>
-            </a:pPr>
-            <a:r>
-              <a:rPr sz="900">
-                <a:solidFill>
-                  <a:srgbClr val="1E1E1E"/>
-                </a:solidFill>
-                <a:latin typeface="Arial"/>
-              </a:rPr>
-              <a:t>• </a:t>
-            </a:r>
-            <a:r>
-              <a:rPr sz="900" b="1">
-                <a:solidFill>
-                  <a:srgbClr val="000000"/>
-                </a:solidFill>
-                <a:latin typeface="Arial"/>
-              </a:rPr>
-              <a:t>Wooster, M. J., et al. (2005): </a:t>
-            </a:r>
-            <a:r>
-              <a:rPr sz="900">
-                <a:solidFill>
-                  <a:srgbClr val="1E1E1E"/>
-                </a:solidFill>
-                <a:latin typeface="Arial"/>
-              </a:rPr>
-              <a:t>"Retrieval of biomass combustion rates and total heat output using Fire Radiative Power (FRP)." J. Geophys. Res.</a:t>
-            </a:r>
-          </a:p>
-        </p:txBody>
-      </p:sp>
-      <p:sp>
-        <p:nvSpPr>
-          <p:cNvPr id="17413" name="TextBox 17412"/>
+              <a:t>UI/UX</a:t>
+            </a:r>
+          </a:p>
+        </p:txBody>
+      </p:sp>
+      <p:pic>
+        <p:nvPicPr>
+          <p:cNvPr id="24" name="Picture 23" descr="image.png"/>
+          <p:cNvPicPr>
+            <a:picLocks noChangeAspect="1"/>
+          </p:cNvPicPr>
+          <p:nvPr/>
+        </p:nvPicPr>
+        <p:blipFill>
+          <a:blip r:embed="rId6"/>
+          <a:stretch>
+            <a:fillRect/>
+          </a:stretch>
+        </p:blipFill>
+        <p:spPr>
+          <a:xfrm>
+            <a:off x="347472" y="3547872"/>
+            <a:ext cx="3621024" cy="2148840"/>
+          </a:xfrm>
+          <a:prstGeom prst="rect">
+            <a:avLst/>
+          </a:prstGeom>
+        </p:spPr>
+      </p:pic>
+      <p:sp>
+        <p:nvSpPr>
+          <p:cNvPr id="25" name="TextBox 24"/>
           <p:cNvSpPr txBox="1"/>
           <p:nvPr/>
         </p:nvSpPr>
         <p:spPr>
           <a:xfrm>
-            <a:off x="5623560" y="1133856"/>
-            <a:ext cx="6217920" cy="4983480"/>
+            <a:off x="347472" y="5751576"/>
+            <a:ext cx="3621024" cy="594360"/>
           </a:xfrm>
           <a:prstGeom prst="rect">
             <a:avLst/>
@@ -10671,202 +10940,182 @@
           <a:p>
             <a:pPr>
               <a:spcAft>
-                <a:spcPts val="400"/>
+                <a:spcPts val="200"/>
               </a:spcAft>
-              <a:defRPr sz="1250" b="1" u="sng">
-                <a:solidFill>
-                  <a:srgbClr val="2B5B84"/>
+              <a:defRPr sz="950" b="1">
+                <a:solidFill>
+                  <a:srgbClr val="0284C7"/>
                 </a:solidFill>
                 <a:latin typeface="Arial"/>
               </a:defRPr>
             </a:pPr>
             <a:r>
-              <a:t>Operational Datasets, APIs &amp; Standards:</a:t>
+              <a:t>3D Geospatial HUD (Cesium WebGL)</a:t>
             </a:r>
           </a:p>
           <a:p>
             <a:pPr>
-              <a:lnSpc>
-                <a:spcPct val="115000"/>
-              </a:lnSpc>
+              <a:defRPr sz="800">
+                <a:solidFill>
+                  <a:srgbClr val="475569"/>
+                </a:solidFill>
+                <a:latin typeface="Arial"/>
+              </a:defRPr>
+            </a:pPr>
+            <a:r>
+              <a:t>Real-time thermal clustering across Indian industrial corridors.</a:t>
+            </a:r>
+          </a:p>
+        </p:txBody>
+      </p:sp>
+      <p:pic>
+        <p:nvPicPr>
+          <p:cNvPr id="26" name="Picture 25" descr="image.jpg"/>
+          <p:cNvPicPr>
+            <a:picLocks noChangeAspect="1"/>
+          </p:cNvPicPr>
+          <p:nvPr/>
+        </p:nvPicPr>
+        <p:blipFill>
+          <a:blip r:embed="rId7"/>
+          <a:stretch>
+            <a:fillRect/>
+          </a:stretch>
+        </p:blipFill>
+        <p:spPr>
+          <a:xfrm>
+            <a:off x="3595347995472" y="3547872"/>
+            <a:ext cx="3621024" cy="2148840"/>
+          </a:xfrm>
+          <a:prstGeom prst="rect">
+            <a:avLst/>
+          </a:prstGeom>
+        </p:spPr>
+      </p:pic>
+      <p:sp>
+        <p:nvSpPr>
+          <p:cNvPr id="27" name="TextBox 26"/>
+          <p:cNvSpPr txBox="1"/>
+          <p:nvPr/>
+        </p:nvSpPr>
+        <p:spPr>
+          <a:xfrm>
+            <a:off x="3595347995472" y="5751576"/>
+            <a:ext cx="3621024" cy="594360"/>
+          </a:xfrm>
+          <a:prstGeom prst="rect">
+            <a:avLst/>
+          </a:prstGeom>
+          <a:noFill/>
+        </p:spPr>
+        <p:txBody>
+          <a:bodyPr wrap="square" lIns="0" rIns="0" tIns="0" bIns="0">
+            <a:spAutoFit/>
+          </a:bodyPr>
+          <a:lstStyle/>
+          <a:p>
+            <a:pPr>
               <a:spcAft>
-                <a:spcPts val="600"/>
+                <a:spcPts val="200"/>
               </a:spcAft>
-            </a:pPr>
-            <a:r>
-              <a:rPr sz="900">
-                <a:solidFill>
-                  <a:srgbClr val="1E1E1E"/>
-                </a:solidFill>
-                <a:latin typeface="Arial"/>
-              </a:rPr>
-              <a:t>• </a:t>
-            </a:r>
-            <a:r>
-              <a:rPr sz="900" b="1">
-                <a:solidFill>
-                  <a:srgbClr val="000000"/>
-                </a:solidFill>
-                <a:latin typeface="Arial"/>
-              </a:rPr>
-              <a:t>NASA FIRMS Telemetry API: </a:t>
-            </a:r>
-            <a:r>
-              <a:rPr sz="900">
-                <a:solidFill>
-                  <a:srgbClr val="1E1E1E"/>
-                </a:solidFill>
-                <a:latin typeface="Arial"/>
-              </a:rPr>
-              <a:t>Near Real-Time thermal anomaly detections from VIIRS (S-NPP, NOAA-20, NOAA-21) and MODIS (Terra/Aqua). https://firms.modaps.eosdis.nasa.gov/</a:t>
+              <a:defRPr sz="950" b="1">
+                <a:solidFill>
+                  <a:srgbClr val="10B981"/>
+                </a:solidFill>
+                <a:latin typeface="Arial"/>
+              </a:defRPr>
+            </a:pPr>
+            <a:r>
+              <a:t>3D Toxic Plume &amp; Evacuation Rings</a:t>
             </a:r>
           </a:p>
           <a:p>
             <a:pPr>
-              <a:lnSpc>
-                <a:spcPct val="115000"/>
-              </a:lnSpc>
+              <a:defRPr sz="800">
+                <a:solidFill>
+                  <a:srgbClr val="475569"/>
+                </a:solidFill>
+                <a:latin typeface="Arial"/>
+              </a:defRPr>
+            </a:pPr>
+            <a:r>
+              <a:t>Atmospheric dispersion driven by live Open-Meteo wind vectors.</a:t>
+            </a:r>
+          </a:p>
+        </p:txBody>
+      </p:sp>
+      <p:pic>
+        <p:nvPicPr>
+          <p:cNvPr id="28" name="Picture 27" descr="image.png"/>
+          <p:cNvPicPr>
+            <a:picLocks noChangeAspect="1"/>
+          </p:cNvPicPr>
+          <p:nvPr/>
+        </p:nvPicPr>
+        <p:blipFill>
+          <a:blip r:embed="rId8"/>
+          <a:stretch>
+            <a:fillRect/>
+          </a:stretch>
+        </p:blipFill>
+        <p:spPr>
+          <a:xfrm>
+            <a:off x="7190695643472" y="3547872"/>
+            <a:ext cx="3621024" cy="2148840"/>
+          </a:xfrm>
+          <a:prstGeom prst="rect">
+            <a:avLst/>
+          </a:prstGeom>
+        </p:spPr>
+      </p:pic>
+      <p:sp>
+        <p:nvSpPr>
+          <p:cNvPr id="29" name="TextBox 28"/>
+          <p:cNvSpPr txBox="1"/>
+          <p:nvPr/>
+        </p:nvSpPr>
+        <p:spPr>
+          <a:xfrm>
+            <a:off x="7190695643472" y="5751576"/>
+            <a:ext cx="3621024" cy="594360"/>
+          </a:xfrm>
+          <a:prstGeom prst="rect">
+            <a:avLst/>
+          </a:prstGeom>
+          <a:noFill/>
+        </p:spPr>
+        <p:txBody>
+          <a:bodyPr wrap="square" lIns="0" rIns="0" tIns="0" bIns="0">
+            <a:spAutoFit/>
+          </a:bodyPr>
+          <a:lstStyle/>
+          <a:p>
+            <a:pPr>
               <a:spcAft>
-                <a:spcPts val="600"/>
+                <a:spcPts val="200"/>
               </a:spcAft>
-            </a:pPr>
-            <a:r>
-              <a:rPr sz="900">
-                <a:solidFill>
-                  <a:srgbClr val="1E1E1E"/>
-                </a:solidFill>
-                <a:latin typeface="Arial"/>
-              </a:rPr>
-              <a:t>• </a:t>
-            </a:r>
-            <a:r>
-              <a:rPr sz="900" b="1">
-                <a:solidFill>
-                  <a:srgbClr val="000000"/>
-                </a:solidFill>
-                <a:latin typeface="Arial"/>
-              </a:rPr>
-              <a:t>ESA WorldCover 10m: </a:t>
-            </a:r>
-            <a:r>
-              <a:rPr sz="900">
-                <a:solidFill>
-                  <a:srgbClr val="1E1E1E"/>
-                </a:solidFill>
-                <a:latin typeface="Arial"/>
-              </a:rPr>
-              <a:t>Global 10m Land Use / Land Cover (LULC) classification based on Sentinel-1 and Sentinel-2 data. European Space Agency.</a:t>
+              <a:defRPr sz="950" b="1">
+                <a:solidFill>
+                  <a:srgbClr val="D97706"/>
+                </a:solidFill>
+                <a:latin typeface="Arial"/>
+              </a:defRPr>
+            </a:pPr>
+            <a:r>
+              <a:t>CAMEO HazMat Dossier &amp; NDRF Dispatch</a:t>
             </a:r>
           </a:p>
           <a:p>
             <a:pPr>
-              <a:lnSpc>
-                <a:spcPct val="115000"/>
-              </a:lnSpc>
-              <a:spcAft>
-                <a:spcPts val="600"/>
-              </a:spcAft>
-            </a:pPr>
-            <a:r>
-              <a:rPr sz="900">
-                <a:solidFill>
-                  <a:srgbClr val="1E1E1E"/>
-                </a:solidFill>
-                <a:latin typeface="Arial"/>
-              </a:rPr>
-              <a:t>• </a:t>
-            </a:r>
-            <a:r>
-              <a:rPr sz="900" b="1">
-                <a:solidFill>
-                  <a:srgbClr val="000000"/>
-                </a:solidFill>
-                <a:latin typeface="Arial"/>
-              </a:rPr>
-              <a:t>Copernicus Sentinel-2 Level-2A: </a:t>
-            </a:r>
-            <a:r>
-              <a:rPr sz="900">
-                <a:solidFill>
-                  <a:srgbClr val="1E1E1E"/>
-                </a:solidFill>
-                <a:latin typeface="Arial"/>
-              </a:rPr>
-              <a:t>Bottom-of-Atmosphere (BOA) surface reflectance for spectral indices (NDVI, NBR, SWIR ratios).</a:t>
-            </a:r>
-          </a:p>
-          <a:p>
-            <a:pPr>
-              <a:lnSpc>
-                <a:spcPct val="115000"/>
-              </a:lnSpc>
-              <a:spcAft>
-                <a:spcPts val="600"/>
-              </a:spcAft>
-            </a:pPr>
-            <a:r>
-              <a:rPr sz="900">
-                <a:solidFill>
-                  <a:srgbClr val="1E1E1E"/>
-                </a:solidFill>
-                <a:latin typeface="Arial"/>
-              </a:rPr>
-              <a:t>• </a:t>
-            </a:r>
-            <a:r>
-              <a:rPr sz="900" b="1">
-                <a:solidFill>
-                  <a:srgbClr val="000000"/>
-                </a:solidFill>
-                <a:latin typeface="Arial"/>
-              </a:rPr>
-              <a:t>NOAA / EPA CAMEO Chemical Database: </a:t>
-            </a:r>
-            <a:r>
-              <a:rPr sz="900">
-                <a:solidFill>
-                  <a:srgbClr val="1E1E1E"/>
-                </a:solidFill>
-                <a:latin typeface="Arial"/>
-              </a:rPr>
-              <a:t>Hazard profiles, toxic isolation distances, IDLH, ERPG, and AEGL concentration thresholds.</a:t>
-            </a:r>
-          </a:p>
-          <a:p>
-            <a:pPr>
-              <a:lnSpc>
-                <a:spcPct val="115000"/>
-              </a:lnSpc>
-              <a:spcAft>
-                <a:spcPts val="600"/>
-              </a:spcAft>
-            </a:pPr>
-            <a:r>
-              <a:rPr sz="900">
-                <a:solidFill>
-                  <a:srgbClr val="1E1E1E"/>
-                </a:solidFill>
-                <a:latin typeface="Arial"/>
-              </a:rPr>
-              <a:t>• </a:t>
-            </a:r>
-            <a:r>
-              <a:rPr sz="900" b="1">
-                <a:solidFill>
-                  <a:srgbClr val="000000"/>
-                </a:solidFill>
-                <a:latin typeface="Arial"/>
-              </a:rPr>
-              <a:t>Open-Meteo Atmospheric Weather API: </a:t>
-            </a:r>
-            <a:r>
-              <a:rPr sz="900">
-                <a:solidFill>
-                  <a:srgbClr val="1E1E1E"/>
-                </a:solidFill>
-                <a:latin typeface="Arial"/>
-              </a:rPr>
-              <a:t>High-resolution real-time boundary layer wind vectors (speed, direction) and ambient surface temperatures.</a:t>
+              <a:defRPr sz="800">
+                <a:solidFill>
+                  <a:srgbClr val="475569"/>
+                </a:solidFill>
+                <a:latin typeface="Arial"/>
+              </a:defRPr>
+            </a:pPr>
+            <a:r>
+              <a:t>Automated Incident Action Plan with SMS/WhatsApp responder routing.</a:t>
             </a:r>
           </a:p>
         </p:txBody>

</xml_diff>

<commit_message>
feat(slide2): implement ATS-friendly 3-column architecture with orbital-to-ground stack and risk vs solution pills
</commit_message>
<xml_diff>
--- a/SIH2026-IDEA-Presentation-Format.pptx
+++ b/SIH2026-IDEA-Presentation-Format.pptx
@@ -6044,44 +6044,6 @@
       </p:sp>
       <p:sp>
         <p:nvSpPr>
-          <p:cNvPr id="15361" name="Title 1"/>
-          <p:cNvSpPr>
-            <a:spLocks noGrp="1"/>
-          </p:cNvSpPr>
-          <p:nvPr>
-            <p:ph type="title"/>
-          </p:nvPr>
-        </p:nvSpPr>
-        <p:spPr>
-          <a:xfrm>
-            <a:off x="1645920" y="109728"/>
-            <a:ext cx="8046720" cy="914400"/>
-          </a:xfrm>
-        </p:spPr>
-        <p:txBody>
-          <a:bodyPr/>
-          <a:lstStyle/>
-          <a:p>
-            <a:pPr eaLnBrk="1" hangingPunct="1" algn="ctr">
-              <a:defRPr sz="1650" b="1">
-                <a:solidFill>
-                  <a:srgbClr val="000000"/>
-                </a:solidFill>
-                <a:latin typeface="Times New Roman"/>
-              </a:defRPr>
-            </a:pPr>
-            <a:r>
-              <a:t>PyroSat: AI-Powered Satellite Thermal Anomaly &amp; Sub-Pixel Inversion</a:t>
-            </a:r>
-            <a:br/>
-            <a:r>
-              <a:t>Platform for Industrial Fire and Disaster Mitigation</a:t>
-            </a:r>
-          </a:p>
-        </p:txBody>
-      </p:sp>
-      <p:sp>
-        <p:nvSpPr>
           <p:cNvPr id="6" name="Slide Number Placeholder 5"/>
           <p:cNvSpPr>
             <a:spLocks noGrp="1"/>
@@ -6239,14 +6201,66 @@
       </p:pic>
       <p:sp>
         <p:nvSpPr>
-          <p:cNvPr id="15362" name="Rectangle 15361"/>
+          <p:cNvPr id="12" name="TextBox 11"/>
+          <p:cNvSpPr txBox="1"/>
+          <p:nvPr/>
+        </p:nvSpPr>
+        <p:spPr>
+          <a:xfrm>
+            <a:off x="1645920" y="91440"/>
+            <a:ext cx="8046720" cy="932688"/>
+          </a:xfrm>
+          <a:prstGeom prst="rect">
+            <a:avLst/>
+          </a:prstGeom>
+          <a:noFill/>
+        </p:spPr>
+        <p:txBody>
+          <a:bodyPr wrap="square" tIns="0" bIns="0" lIns="0" rIns="0">
+            <a:spAutoFit/>
+          </a:bodyPr>
+          <a:lstStyle/>
+          <a:p>
+            <a:pPr algn="ctr">
+              <a:spcAft>
+                <a:spcPts val="200"/>
+              </a:spcAft>
+              <a:defRPr sz="1700" b="1">
+                <a:solidFill>
+                  <a:srgbClr val="0F172A"/>
+                </a:solidFill>
+                <a:latin typeface="Arial"/>
+              </a:defRPr>
+            </a:pPr>
+            <a:r>
+              <a:t>PyroSat: AI-Powered Satellite Thermal Intelligence</a:t>
+            </a:r>
+          </a:p>
+          <a:p>
+            <a:pPr algn="ctr">
+              <a:defRPr sz="950" b="1">
+                <a:solidFill>
+                  <a:srgbClr val="475569"/>
+                </a:solidFill>
+                <a:latin typeface="Arial"/>
+              </a:defRPr>
+            </a:pPr>
+            <a:r>
+              <a:t>Precision Sub-Pixel Pyrometry, Industrial Fire Segregation &amp; Real-Time Toxic Plume Defense for India</a:t>
+            </a:r>
+          </a:p>
+        </p:txBody>
+      </p:sp>
+      <p:sp>
+        <p:nvSpPr>
+          <p:cNvPr id="13" name="Rectangle 12"/>
           <p:cNvSpPr/>
           <p:nvPr/>
         </p:nvSpPr>
         <p:spPr>
           <a:xfrm>
-            <a:off x="256032" y="1078992"/>
-            <a:ext cx="11658600" cy="18288"/>
+            <a:off x="347472" y="1078992"/>
+            <a:ext cx="11484864" cy="18288"/>
           </a:xfrm>
           <a:prstGeom prst="rect">
             <a:avLst/>
@@ -6282,23 +6296,25 @@
       </p:sp>
       <p:sp>
         <p:nvSpPr>
-          <p:cNvPr id="15363" name="Rectangle 15362"/>
+          <p:cNvPr id="14" name="Rounded Rectangle 13"/>
           <p:cNvSpPr/>
           <p:nvPr/>
         </p:nvSpPr>
         <p:spPr>
           <a:xfrm>
-            <a:off x="256032" y="2450592"/>
-            <a:ext cx="11658600" cy="13716"/>
-          </a:xfrm>
-          <a:prstGeom prst="rect">
+            <a:off x="347472" y="1170432"/>
+            <a:ext cx="3474720" cy="1078992"/>
+          </a:xfrm>
+          <a:prstGeom prst="roundRect">
             <a:avLst/>
           </a:prstGeom>
           <a:solidFill>
-            <a:srgbClr val="B9C3CD"/>
+            <a:srgbClr val="1E293B"/>
           </a:solidFill>
-          <a:ln>
-            <a:noFill/>
+          <a:ln w="12700">
+            <a:solidFill>
+              <a:srgbClr val="334155"/>
+            </a:solidFill>
           </a:ln>
         </p:spPr>
         <p:style>
@@ -6325,23 +6341,77 @@
       </p:sp>
       <p:sp>
         <p:nvSpPr>
-          <p:cNvPr id="15364" name="Rectangle 15363"/>
-          <p:cNvSpPr/>
+          <p:cNvPr id="15" name="TextBox 14"/>
+          <p:cNvSpPr txBox="1"/>
           <p:nvPr/>
         </p:nvSpPr>
         <p:spPr>
           <a:xfrm>
-            <a:off x="5440680" y="1115568"/>
-            <a:ext cx="13716" cy="1298448"/>
+            <a:off x="457200" y="1243584"/>
+            <a:ext cx="3255264" cy="950976"/>
           </a:xfrm>
           <a:prstGeom prst="rect">
             <a:avLst/>
           </a:prstGeom>
+          <a:noFill/>
+        </p:spPr>
+        <p:txBody>
+          <a:bodyPr wrap="square" lIns="0" rIns="0" tIns="0" bIns="0">
+            <a:spAutoFit/>
+          </a:bodyPr>
+          <a:lstStyle/>
+          <a:p>
+            <a:pPr>
+              <a:spcAft>
+                <a:spcPts val="200"/>
+              </a:spcAft>
+              <a:defRPr sz="950" b="1">
+                <a:solidFill>
+                  <a:srgbClr val="F59E0B"/>
+                </a:solidFill>
+                <a:latin typeface="Arial"/>
+              </a:defRPr>
+            </a:pPr>
+            <a:r>
+              <a:t>Real-World Issue:</a:t>
+            </a:r>
+          </a:p>
+          <a:p>
+            <a:pPr>
+              <a:defRPr sz="780">
+                <a:solidFill>
+                  <a:srgbClr val="F8FAFC"/>
+                </a:solidFill>
+                <a:latin typeface="Arial"/>
+              </a:defRPr>
+            </a:pPr>
+            <a:r>
+              <a:t>Coarse 375m satellite thermal pixels cannot distinguish routine industrial flaring from runaway refinery explosions or crop stubble, causing severe operational blindness.</a:t>
+            </a:r>
+          </a:p>
+        </p:txBody>
+      </p:sp>
+      <p:sp>
+        <p:nvSpPr>
+          <p:cNvPr id="16" name="Rounded Rectangle 15"/>
+          <p:cNvSpPr/>
+          <p:nvPr/>
+        </p:nvSpPr>
+        <p:spPr>
+          <a:xfrm>
+            <a:off x="347472" y="2359152"/>
+            <a:ext cx="3474720" cy="1078992"/>
+          </a:xfrm>
+          <a:prstGeom prst="roundRect">
+            <a:avLst/>
+          </a:prstGeom>
           <a:solidFill>
-            <a:srgbClr val="B9C3CD"/>
+            <a:srgbClr val="1E293B"/>
           </a:solidFill>
-          <a:ln>
-            <a:noFill/>
+          <a:ln w="12700">
+            <a:solidFill>
+              <a:srgbClr val="334155"/>
+            </a:solidFill>
           </a:ln>
         </p:spPr>
         <p:style>
@@ -6368,14 +6438,14 @@
       </p:sp>
       <p:sp>
         <p:nvSpPr>
-          <p:cNvPr id="15365" name="TextBox 15364"/>
+          <p:cNvPr id="17" name="TextBox 16"/>
           <p:cNvSpPr txBox="1"/>
           <p:nvPr/>
         </p:nvSpPr>
         <p:spPr>
           <a:xfrm>
-            <a:off x="347472" y="1143000"/>
-            <a:ext cx="4937760" cy="1234440"/>
+            <a:off x="457200" y="2432304"/>
+            <a:ext cx="3255264" cy="950976"/>
           </a:xfrm>
           <a:prstGeom prst="rect">
             <a:avLst/>
@@ -6390,74 +6460,89 @@
           <a:p>
             <a:pPr>
               <a:spcAft>
-                <a:spcPts val="400"/>
+                <a:spcPts val="200"/>
               </a:spcAft>
-              <a:defRPr sz="1250" b="1" u="sng">
-                <a:solidFill>
-                  <a:srgbClr val="2B5B84"/>
+              <a:defRPr sz="950" b="1">
+                <a:solidFill>
+                  <a:srgbClr val="F59E0B"/>
                 </a:solidFill>
                 <a:latin typeface="Arial"/>
               </a:defRPr>
             </a:pPr>
             <a:r>
-              <a:t>Problem:</a:t>
+              <a:t>Why Important:</a:t>
             </a:r>
           </a:p>
           <a:p>
             <a:pPr>
-              <a:lnSpc>
-                <a:spcPct val="115000"/>
-              </a:lnSpc>
-            </a:pPr>
-            <a:r>
-              <a:rPr sz="1000">
-                <a:solidFill>
-                  <a:srgbClr val="232323"/>
-                </a:solidFill>
-                <a:latin typeface="Arial"/>
-              </a:rPr>
-              <a:t>NASA FIRMS satellites detect heat, but </a:t>
-            </a:r>
-            <a:r>
-              <a:rPr sz="1000" b="1">
-                <a:solidFill>
-                  <a:srgbClr val="000000"/>
-                </a:solidFill>
-                <a:latin typeface="Arial"/>
-              </a:rPr>
-              <a:t>cannot tell what is burning.</a:t>
-            </a:r>
-            <a:r>
-              <a:rPr sz="1000">
-                <a:solidFill>
-                  <a:srgbClr val="232323"/>
-                </a:solidFill>
-                <a:latin typeface="Arial"/>
-              </a:rPr>
-              <a:t> Coarse 375m pixels mix routine refinery flares with runaway chemical explosions and wildfires. In industrial corridors, this causes </a:t>
-            </a:r>
-            <a:r>
-              <a:rPr sz="1000" b="1">
-                <a:solidFill>
-                  <a:srgbClr val="000000"/>
-                </a:solidFill>
-                <a:latin typeface="Arial"/>
-              </a:rPr>
-              <a:t>heavy false alarms, putting critical infrastructure and lives at risk.</a:t>
-            </a:r>
-          </a:p>
-        </p:txBody>
-      </p:sp>
-      <p:sp>
-        <p:nvSpPr>
-          <p:cNvPr id="15366" name="TextBox 15365"/>
+              <a:defRPr sz="780">
+                <a:solidFill>
+                  <a:srgbClr val="F8FAFC"/>
+                </a:solidFill>
+                <a:latin typeface="Arial"/>
+              </a:defRPr>
+            </a:pPr>
+            <a:r>
+              <a:t>India houses 2,000+ hazardous petrochemical and industrial facilities near dense populations. Delayed hazard response risks thousands of lives and ₹10,000+ Cr in critical assets.</a:t>
+            </a:r>
+          </a:p>
+        </p:txBody>
+      </p:sp>
+      <p:sp>
+        <p:nvSpPr>
+          <p:cNvPr id="18" name="Rounded Rectangle 17"/>
+          <p:cNvSpPr/>
+          <p:nvPr/>
+        </p:nvSpPr>
+        <p:spPr>
+          <a:xfrm>
+            <a:off x="347472" y="3547872"/>
+            <a:ext cx="3474720" cy="1143000"/>
+          </a:xfrm>
+          <a:prstGeom prst="roundRect">
+            <a:avLst/>
+          </a:prstGeom>
+          <a:solidFill>
+            <a:srgbClr val="1E293B"/>
+          </a:solidFill>
+          <a:ln w="12700">
+            <a:solidFill>
+              <a:srgbClr val="334155"/>
+            </a:solidFill>
+          </a:ln>
+        </p:spPr>
+        <p:style>
+          <a:lnRef idx="1">
+            <a:schemeClr val="accent1"/>
+          </a:lnRef>
+          <a:fillRef idx="3">
+            <a:schemeClr val="accent1"/>
+          </a:fillRef>
+          <a:effectRef idx="2">
+            <a:schemeClr val="accent1"/>
+          </a:effectRef>
+          <a:fontRef idx="minor">
+            <a:schemeClr val="lt1"/>
+          </a:fontRef>
+        </p:style>
+        <p:txBody>
+          <a:bodyPr rtlCol="0" anchor="ctr"/>
+          <a:lstStyle/>
+          <a:p>
+            <a:pPr algn="ctr"/>
+          </a:p>
+        </p:txBody>
+      </p:sp>
+      <p:sp>
+        <p:nvSpPr>
+          <p:cNvPr id="19" name="TextBox 18"/>
           <p:cNvSpPr txBox="1"/>
           <p:nvPr/>
         </p:nvSpPr>
         <p:spPr>
           <a:xfrm>
-            <a:off x="5623560" y="1143000"/>
-            <a:ext cx="6217920" cy="1234440"/>
+            <a:off x="457200" y="3621024"/>
+            <a:ext cx="3255264" cy="1014984"/>
           </a:xfrm>
           <a:prstGeom prst="rect">
             <a:avLst/>
@@ -6472,74 +6557,89 @@
           <a:p>
             <a:pPr>
               <a:spcAft>
-                <a:spcPts val="400"/>
+                <a:spcPts val="200"/>
               </a:spcAft>
-              <a:defRPr sz="1250" b="1" u="sng">
-                <a:solidFill>
-                  <a:srgbClr val="2B5B84"/>
+              <a:defRPr sz="950" b="1">
+                <a:solidFill>
+                  <a:srgbClr val="38BDF8"/>
                 </a:solidFill>
                 <a:latin typeface="Arial"/>
               </a:defRPr>
             </a:pPr>
             <a:r>
-              <a:t>Our Idea :</a:t>
+              <a:t>Proposed Solution:</a:t>
             </a:r>
           </a:p>
           <a:p>
             <a:pPr>
-              <a:lnSpc>
-                <a:spcPct val="115000"/>
-              </a:lnSpc>
-            </a:pPr>
-            <a:r>
-              <a:rPr sz="1000" b="1">
-                <a:solidFill>
-                  <a:srgbClr val="000000"/>
-                </a:solidFill>
-                <a:latin typeface="Arial"/>
-              </a:rPr>
-              <a:t>PyroSat is an AI-powered platform with a three-pillar approach </a:t>
-            </a:r>
-            <a:r>
-              <a:rPr sz="1000">
-                <a:solidFill>
-                  <a:srgbClr val="232323"/>
-                </a:solidFill>
-                <a:latin typeface="Arial"/>
-              </a:rPr>
-              <a:t>ensuring automated disaster intelligence when orbital feeds are ambiguous. It combines </a:t>
-            </a:r>
-            <a:r>
-              <a:rPr sz="1000" b="1">
-                <a:solidFill>
-                  <a:srgbClr val="000000"/>
-                </a:solidFill>
-                <a:latin typeface="Arial"/>
-              </a:rPr>
-              <a:t>infrared flame physics, hierarchical ML, and 3D GIS maps </a:t>
-            </a:r>
-            <a:r>
-              <a:rPr sz="1000">
-                <a:solidFill>
-                  <a:srgbClr val="232323"/>
-                </a:solidFill>
-                <a:latin typeface="Arial"/>
-              </a:rPr>
-              <a:t>to deliver instant emergency alerts and toxic plume evacuation modeling.</a:t>
-            </a:r>
-          </a:p>
-        </p:txBody>
-      </p:sp>
-      <p:sp>
-        <p:nvSpPr>
-          <p:cNvPr id="15367" name="TextBox 15366"/>
+              <a:defRPr sz="780">
+                <a:solidFill>
+                  <a:srgbClr val="F8FAFC"/>
+                </a:solidFill>
+                <a:latin typeface="Arial"/>
+              </a:defRPr>
+            </a:pPr>
+            <a:r>
+              <a:t>PyroSat solves sub-pixel flame temperature (Tf &gt; 1100 K) and burning area via Planck pyrometry, eliminates false alarms using 10m ESA ground truth, and projects live 3D evacuation zones.</a:t>
+            </a:r>
+          </a:p>
+        </p:txBody>
+      </p:sp>
+      <p:sp>
+        <p:nvSpPr>
+          <p:cNvPr id="20" name="Rounded Rectangle 19"/>
+          <p:cNvSpPr/>
+          <p:nvPr/>
+        </p:nvSpPr>
+        <p:spPr>
+          <a:xfrm>
+            <a:off x="347472" y="4800600"/>
+            <a:ext cx="3474720" cy="1371600"/>
+          </a:xfrm>
+          <a:prstGeom prst="roundRect">
+            <a:avLst/>
+          </a:prstGeom>
+          <a:solidFill>
+            <a:srgbClr val="F0F9FF"/>
+          </a:solidFill>
+          <a:ln w="15240">
+            <a:solidFill>
+              <a:srgbClr val="BAE6FD"/>
+            </a:solidFill>
+          </a:ln>
+        </p:spPr>
+        <p:style>
+          <a:lnRef idx="1">
+            <a:schemeClr val="accent1"/>
+          </a:lnRef>
+          <a:fillRef idx="3">
+            <a:schemeClr val="accent1"/>
+          </a:fillRef>
+          <a:effectRef idx="2">
+            <a:schemeClr val="accent1"/>
+          </a:effectRef>
+          <a:fontRef idx="minor">
+            <a:schemeClr val="lt1"/>
+          </a:fontRef>
+        </p:style>
+        <p:txBody>
+          <a:bodyPr rtlCol="0" anchor="ctr"/>
+          <a:lstStyle/>
+          <a:p>
+            <a:pPr algn="ctr"/>
+          </a:p>
+        </p:txBody>
+      </p:sp>
+      <p:sp>
+        <p:nvSpPr>
+          <p:cNvPr id="21" name="TextBox 20"/>
           <p:cNvSpPr txBox="1"/>
           <p:nvPr/>
         </p:nvSpPr>
         <p:spPr>
           <a:xfrm>
-            <a:off x="347472" y="2542032"/>
-            <a:ext cx="3840480" cy="3657600"/>
+            <a:off x="475488" y="4873752"/>
+            <a:ext cx="3218688" cy="1243584"/>
           </a:xfrm>
           <a:prstGeom prst="rect">
             <a:avLst/>
@@ -6554,142 +6654,59 @@
           <a:p>
             <a:pPr>
               <a:spcAft>
-                <a:spcPts val="600"/>
+                <a:spcPts val="300"/>
               </a:spcAft>
-              <a:defRPr sz="1250" b="1" u="sng">
-                <a:solidFill>
-                  <a:srgbClr val="2B5B84"/>
+              <a:defRPr sz="900" b="1">
+                <a:solidFill>
+                  <a:srgbClr val="0369A1"/>
                 </a:solidFill>
                 <a:latin typeface="Arial"/>
               </a:defRPr>
             </a:pPr>
             <a:r>
-              <a:t>Proposed Solution :</a:t>
+              <a:t>⚡ Working Prototype &amp; Demonstrations:</a:t>
             </a:r>
           </a:p>
           <a:p>
             <a:pPr>
-              <a:lnSpc>
-                <a:spcPct val="115000"/>
-              </a:lnSpc>
               <a:spcAft>
-                <a:spcPts val="700"/>
+                <a:spcPts val="300"/>
               </a:spcAft>
             </a:pPr>
             <a:r>
-              <a:rPr sz="950">
-                <a:solidFill>
-                  <a:srgbClr val="232323"/>
-                </a:solidFill>
-                <a:latin typeface="Arial"/>
-              </a:rPr>
-              <a:t>• When satellite telemetry arrives, the system applies </a:t>
-            </a:r>
-            <a:r>
-              <a:rPr sz="950" b="1">
-                <a:solidFill>
-                  <a:srgbClr val="000000"/>
-                </a:solidFill>
-                <a:latin typeface="Arial"/>
-              </a:rPr>
-              <a:t>Dual-Band Planck Pyrometry</a:t>
-            </a:r>
-            <a:r>
-              <a:rPr sz="950">
-                <a:solidFill>
-                  <a:srgbClr val="232323"/>
-                </a:solidFill>
-                <a:latin typeface="Arial"/>
-              </a:rPr>
-              <a:t> to calculate true flame temperature (Tf &gt; 1200 K) and exact fire area from sub-pixel clutter.</a:t>
-            </a:r>
-          </a:p>
-          <a:p>
-            <a:pPr>
-              <a:lnSpc>
-                <a:spcPct val="115000"/>
-              </a:lnSpc>
-              <a:spcAft>
-                <a:spcPts val="700"/>
-              </a:spcAft>
-            </a:pPr>
-            <a:r>
-              <a:rPr sz="950">
-                <a:solidFill>
-                  <a:srgbClr val="232323"/>
-                </a:solidFill>
-                <a:latin typeface="Arial"/>
-              </a:rPr>
-              <a:t>• A </a:t>
-            </a:r>
-            <a:r>
-              <a:rPr sz="950" b="1">
-                <a:solidFill>
-                  <a:srgbClr val="000000"/>
-                </a:solidFill>
-                <a:latin typeface="Arial"/>
-              </a:rPr>
-              <a:t>2-Stage Hierarchical ML Classifier</a:t>
-            </a:r>
-            <a:r>
-              <a:rPr sz="950">
-                <a:solidFill>
-                  <a:srgbClr val="232323"/>
-                </a:solidFill>
-                <a:latin typeface="Arial"/>
-              </a:rPr>
-              <a:t> automatically segregates routine refinery flares from industrial explosions and forest wildfires.</a:t>
-            </a:r>
-          </a:p>
-          <a:p>
-            <a:pPr>
-              <a:lnSpc>
-                <a:spcPct val="115000"/>
-              </a:lnSpc>
-              <a:spcAft>
-                <a:spcPts val="700"/>
-              </a:spcAft>
-            </a:pPr>
-            <a:r>
-              <a:rPr sz="950">
-                <a:solidFill>
-                  <a:srgbClr val="232323"/>
-                </a:solidFill>
-                <a:latin typeface="Arial"/>
-              </a:rPr>
-              <a:t>• An integrated </a:t>
-            </a:r>
-            <a:r>
-              <a:rPr sz="950" b="1">
-                <a:solidFill>
-                  <a:srgbClr val="000000"/>
-                </a:solidFill>
-                <a:latin typeface="Arial"/>
-              </a:rPr>
-              <a:t>3D GIS WebGL Command Dashboard</a:t>
-            </a:r>
-            <a:r>
-              <a:rPr sz="950">
-                <a:solidFill>
-                  <a:srgbClr val="232323"/>
-                </a:solidFill>
-                <a:latin typeface="Arial"/>
-              </a:rPr>
-              <a:t> drapes thermal hotspots and real-time Gaussian toxic plume evacuation zones onto a live virtual globe.</a:t>
-            </a:r>
-          </a:p>
-        </p:txBody>
-      </p:sp>
-      <p:sp>
-        <p:nvSpPr>
-          <p:cNvPr id="15368" name="TextBox 15367"/>
+              <a:rPr sz="780" b="1" u="sng">
+                <a:solidFill>
+                  <a:srgbClr val="0284C7"/>
+                </a:solidFill>
+                <a:latin typeface="Arial"/>
+                <a:hlinkClick r:id="rId4"/>
+              </a:rPr>
+              <a:t>🔗 Live Cloud Platform: pyrosat-intelligence.onrender.com</a:t>
+            </a:r>
+          </a:p>
+          <a:p>
+            <a:r>
+              <a:rPr sz="750">
+                <a:solidFill>
+                  <a:srgbClr val="475569"/>
+                </a:solidFill>
+                <a:latin typeface="Arial"/>
+              </a:rPr>
+              <a:t>🔗 Technical Defense &amp; Benchmark Replay: GROUND_TRUTH_DEFENSE</a:t>
+            </a:r>
+          </a:p>
+        </p:txBody>
+      </p:sp>
+      <p:sp>
+        <p:nvSpPr>
+          <p:cNvPr id="22" name="TextBox 21"/>
           <p:cNvSpPr txBox="1"/>
           <p:nvPr/>
         </p:nvSpPr>
         <p:spPr>
           <a:xfrm>
-            <a:off x="8001000" y="2542032"/>
-            <a:ext cx="3840480" cy="3657600"/>
+            <a:off x="4005072" y="1115568"/>
+            <a:ext cx="4160520" cy="256032"/>
           </a:xfrm>
           <a:prstGeom prst="rect">
             <a:avLst/>
@@ -6697,6 +6714,176 @@
           <a:noFill/>
         </p:spPr>
         <p:txBody>
+          <a:bodyPr wrap="none" lIns="0" rIns="0" tIns="0" bIns="0">
+            <a:spAutoFit/>
+          </a:bodyPr>
+          <a:lstStyle/>
+          <a:p>
+            <a:pPr algn="ctr">
+              <a:defRPr sz="900" b="1">
+                <a:solidFill>
+                  <a:srgbClr val="1E3A8A"/>
+                </a:solidFill>
+                <a:latin typeface="Arial"/>
+              </a:defRPr>
+            </a:pPr>
+            <a:r>
+              <a:t>CORE ARCHITECTURE: ORBITAL-TO-GROUND PIPELINE</a:t>
+            </a:r>
+          </a:p>
+        </p:txBody>
+      </p:sp>
+      <p:sp>
+        <p:nvSpPr>
+          <p:cNvPr id="23" name="Rounded Rectangle 22"/>
+          <p:cNvSpPr/>
+          <p:nvPr/>
+        </p:nvSpPr>
+        <p:spPr>
+          <a:xfrm>
+            <a:off x="4005072" y="1389888"/>
+            <a:ext cx="4160520" cy="1051560"/>
+          </a:xfrm>
+          <a:prstGeom prst="roundRect">
+            <a:avLst/>
+          </a:prstGeom>
+          <a:solidFill>
+            <a:srgbClr val="F8FAFC"/>
+          </a:solidFill>
+          <a:ln w="15240">
+            <a:solidFill>
+              <a:srgbClr val="BAE6FD"/>
+            </a:solidFill>
+          </a:ln>
+        </p:spPr>
+        <p:style>
+          <a:lnRef idx="1">
+            <a:schemeClr val="accent1"/>
+          </a:lnRef>
+          <a:fillRef idx="3">
+            <a:schemeClr val="accent1"/>
+          </a:fillRef>
+          <a:effectRef idx="2">
+            <a:schemeClr val="accent1"/>
+          </a:effectRef>
+          <a:fontRef idx="minor">
+            <a:schemeClr val="lt1"/>
+          </a:fontRef>
+        </p:style>
+        <p:txBody>
+          <a:bodyPr rtlCol="0" anchor="ctr"/>
+          <a:lstStyle/>
+          <a:p>
+            <a:pPr algn="ctr"/>
+          </a:p>
+        </p:txBody>
+      </p:sp>
+      <p:sp>
+        <p:nvSpPr>
+          <p:cNvPr id="24" name="Rounded Rectangle 23"/>
+          <p:cNvSpPr/>
+          <p:nvPr/>
+        </p:nvSpPr>
+        <p:spPr>
+          <a:xfrm>
+            <a:off x="4078224" y="1481328"/>
+            <a:ext cx="777240" cy="237744"/>
+          </a:xfrm>
+          <a:prstGeom prst="roundRect">
+            <a:avLst/>
+          </a:prstGeom>
+          <a:solidFill>
+            <a:srgbClr val="0284C7"/>
+          </a:solidFill>
+          <a:ln>
+            <a:noFill/>
+          </a:ln>
+        </p:spPr>
+        <p:style>
+          <a:lnRef idx="1">
+            <a:schemeClr val="accent1"/>
+          </a:lnRef>
+          <a:fillRef idx="3">
+            <a:schemeClr val="accent1"/>
+          </a:fillRef>
+          <a:effectRef idx="2">
+            <a:schemeClr val="accent1"/>
+          </a:effectRef>
+          <a:fontRef idx="minor">
+            <a:schemeClr val="lt1"/>
+          </a:fontRef>
+        </p:style>
+        <p:txBody>
+          <a:bodyPr rtlCol="0" anchor="ctr"/>
+          <a:lstStyle/>
+          <a:p>
+            <a:pPr algn="ctr">
+              <a:defRPr sz="750" b="1">
+                <a:solidFill>
+                  <a:srgbClr val="F8FAFC"/>
+                </a:solidFill>
+                <a:latin typeface="Arial"/>
+              </a:defRPr>
+            </a:pPr>
+            <a:r>
+              <a:t>LAYER 1</a:t>
+            </a:r>
+          </a:p>
+        </p:txBody>
+      </p:sp>
+      <p:sp>
+        <p:nvSpPr>
+          <p:cNvPr id="25" name="TextBox 24"/>
+          <p:cNvSpPr txBox="1"/>
+          <p:nvPr/>
+        </p:nvSpPr>
+        <p:spPr>
+          <a:xfrm>
+            <a:off x="4937760" y="1463040"/>
+            <a:ext cx="3136392" cy="274320"/>
+          </a:xfrm>
+          <a:prstGeom prst="rect">
+            <a:avLst/>
+          </a:prstGeom>
+          <a:noFill/>
+        </p:spPr>
+        <p:txBody>
+          <a:bodyPr wrap="none" lIns="0" rIns="0" tIns="0" bIns="0">
+            <a:spAutoFit/>
+          </a:bodyPr>
+          <a:lstStyle/>
+          <a:p>
+            <a:pPr>
+              <a:defRPr sz="900" b="1">
+                <a:solidFill>
+                  <a:srgbClr val="0F172A"/>
+                </a:solidFill>
+                <a:latin typeface="Arial"/>
+              </a:defRPr>
+            </a:pPr>
+            <a:r>
+              <a:t>Spaceborne Telemetry Ingestion</a:t>
+            </a:r>
+          </a:p>
+        </p:txBody>
+      </p:sp>
+      <p:sp>
+        <p:nvSpPr>
+          <p:cNvPr id="26" name="TextBox 25"/>
+          <p:cNvSpPr txBox="1"/>
+          <p:nvPr/>
+        </p:nvSpPr>
+        <p:spPr>
+          <a:xfrm>
+            <a:off x="4151376" y="1773936"/>
+            <a:ext cx="3867912" cy="612648"/>
+          </a:xfrm>
+          <a:prstGeom prst="rect">
+            <a:avLst/>
+          </a:prstGeom>
+          <a:noFill/>
+        </p:spPr>
+        <p:txBody>
           <a:bodyPr wrap="square" lIns="0" rIns="0" tIns="0" bIns="0">
             <a:spAutoFit/>
           </a:bodyPr>
@@ -6704,165 +6891,1413 @@
           <a:p>
             <a:pPr>
               <a:spcAft>
-                <a:spcPts val="600"/>
+                <a:spcPts val="200"/>
               </a:spcAft>
-              <a:defRPr sz="1250" b="1" u="sng">
-                <a:solidFill>
-                  <a:srgbClr val="2B5B84"/>
+              <a:defRPr sz="750">
+                <a:solidFill>
+                  <a:srgbClr val="334155"/>
                 </a:solidFill>
                 <a:latin typeface="Arial"/>
               </a:defRPr>
             </a:pPr>
             <a:r>
-              <a:t>Innovation/Uniqueness:</a:t>
+              <a:t>• NASA VIIRS (375m) &amp; MODIS 1km NRT thermal radiance ingestion.</a:t>
             </a:r>
           </a:p>
           <a:p>
             <a:pPr>
-              <a:lnSpc>
-                <a:spcPct val="115000"/>
-              </a:lnSpc>
+              <a:defRPr sz="750">
+                <a:solidFill>
+                  <a:srgbClr val="334155"/>
+                </a:solidFill>
+                <a:latin typeface="Arial"/>
+              </a:defRPr>
+            </a:pPr>
+            <a:r>
+              <a:t>• Active LEO blind-window gap fill &amp; continuous pass monitoring.</a:t>
+            </a:r>
+          </a:p>
+        </p:txBody>
+      </p:sp>
+      <p:sp>
+        <p:nvSpPr>
+          <p:cNvPr id="27" name="Down Arrow 26"/>
+          <p:cNvSpPr/>
+          <p:nvPr/>
+        </p:nvSpPr>
+        <p:spPr>
+          <a:xfrm>
+            <a:off x="5993892" y="2450592"/>
+            <a:ext cx="182880" cy="118872"/>
+          </a:xfrm>
+          <a:prstGeom prst="downArrow">
+            <a:avLst/>
+          </a:prstGeom>
+          <a:solidFill>
+            <a:srgbClr val="94A3B8"/>
+          </a:solidFill>
+          <a:ln>
+            <a:noFill/>
+          </a:ln>
+        </p:spPr>
+        <p:style>
+          <a:lnRef idx="1">
+            <a:schemeClr val="accent1"/>
+          </a:lnRef>
+          <a:fillRef idx="3">
+            <a:schemeClr val="accent1"/>
+          </a:fillRef>
+          <a:effectRef idx="2">
+            <a:schemeClr val="accent1"/>
+          </a:effectRef>
+          <a:fontRef idx="minor">
+            <a:schemeClr val="lt1"/>
+          </a:fontRef>
+        </p:style>
+        <p:txBody>
+          <a:bodyPr rtlCol="0" anchor="ctr"/>
+          <a:lstStyle/>
+          <a:p>
+            <a:pPr algn="ctr"/>
+          </a:p>
+        </p:txBody>
+      </p:sp>
+      <p:sp>
+        <p:nvSpPr>
+          <p:cNvPr id="28" name="Rounded Rectangle 27"/>
+          <p:cNvSpPr/>
+          <p:nvPr/>
+        </p:nvSpPr>
+        <p:spPr>
+          <a:xfrm>
+            <a:off x="4005072" y="2578608"/>
+            <a:ext cx="4160520" cy="1051560"/>
+          </a:xfrm>
+          <a:prstGeom prst="roundRect">
+            <a:avLst/>
+          </a:prstGeom>
+          <a:solidFill>
+            <a:srgbClr val="EEF2FF"/>
+          </a:solidFill>
+          <a:ln w="15240">
+            <a:solidFill>
+              <a:srgbClr val="C7D2FE"/>
+            </a:solidFill>
+          </a:ln>
+        </p:spPr>
+        <p:style>
+          <a:lnRef idx="1">
+            <a:schemeClr val="accent1"/>
+          </a:lnRef>
+          <a:fillRef idx="3">
+            <a:schemeClr val="accent1"/>
+          </a:fillRef>
+          <a:effectRef idx="2">
+            <a:schemeClr val="accent1"/>
+          </a:effectRef>
+          <a:fontRef idx="minor">
+            <a:schemeClr val="lt1"/>
+          </a:fontRef>
+        </p:style>
+        <p:txBody>
+          <a:bodyPr rtlCol="0" anchor="ctr"/>
+          <a:lstStyle/>
+          <a:p>
+            <a:pPr algn="ctr"/>
+          </a:p>
+        </p:txBody>
+      </p:sp>
+      <p:sp>
+        <p:nvSpPr>
+          <p:cNvPr id="29" name="Rounded Rectangle 28"/>
+          <p:cNvSpPr/>
+          <p:nvPr/>
+        </p:nvSpPr>
+        <p:spPr>
+          <a:xfrm>
+            <a:off x="4078224" y="2670048"/>
+            <a:ext cx="777240" cy="237744"/>
+          </a:xfrm>
+          <a:prstGeom prst="roundRect">
+            <a:avLst/>
+          </a:prstGeom>
+          <a:solidFill>
+            <a:srgbClr val="4F46E5"/>
+          </a:solidFill>
+          <a:ln>
+            <a:noFill/>
+          </a:ln>
+        </p:spPr>
+        <p:style>
+          <a:lnRef idx="1">
+            <a:schemeClr val="accent1"/>
+          </a:lnRef>
+          <a:fillRef idx="3">
+            <a:schemeClr val="accent1"/>
+          </a:fillRef>
+          <a:effectRef idx="2">
+            <a:schemeClr val="accent1"/>
+          </a:effectRef>
+          <a:fontRef idx="minor">
+            <a:schemeClr val="lt1"/>
+          </a:fontRef>
+        </p:style>
+        <p:txBody>
+          <a:bodyPr rtlCol="0" anchor="ctr"/>
+          <a:lstStyle/>
+          <a:p>
+            <a:pPr algn="ctr">
+              <a:defRPr sz="750" b="1">
+                <a:solidFill>
+                  <a:srgbClr val="F8FAFC"/>
+                </a:solidFill>
+                <a:latin typeface="Arial"/>
+              </a:defRPr>
+            </a:pPr>
+            <a:r>
+              <a:t>LAYER 2</a:t>
+            </a:r>
+          </a:p>
+        </p:txBody>
+      </p:sp>
+      <p:sp>
+        <p:nvSpPr>
+          <p:cNvPr id="30" name="TextBox 29"/>
+          <p:cNvSpPr txBox="1"/>
+          <p:nvPr/>
+        </p:nvSpPr>
+        <p:spPr>
+          <a:xfrm>
+            <a:off x="4937760" y="2651760"/>
+            <a:ext cx="3136392" cy="274320"/>
+          </a:xfrm>
+          <a:prstGeom prst="rect">
+            <a:avLst/>
+          </a:prstGeom>
+          <a:noFill/>
+        </p:spPr>
+        <p:txBody>
+          <a:bodyPr wrap="none" lIns="0" rIns="0" tIns="0" bIns="0">
+            <a:spAutoFit/>
+          </a:bodyPr>
+          <a:lstStyle/>
+          <a:p>
+            <a:pPr>
+              <a:defRPr sz="900" b="1">
+                <a:solidFill>
+                  <a:srgbClr val="0F172A"/>
+                </a:solidFill>
+                <a:latin typeface="Arial"/>
+              </a:defRPr>
+            </a:pPr>
+            <a:r>
+              <a:t>Sub-Pixel Infrared Planck Pyrometry</a:t>
+            </a:r>
+          </a:p>
+        </p:txBody>
+      </p:sp>
+      <p:sp>
+        <p:nvSpPr>
+          <p:cNvPr id="31" name="TextBox 30"/>
+          <p:cNvSpPr txBox="1"/>
+          <p:nvPr/>
+        </p:nvSpPr>
+        <p:spPr>
+          <a:xfrm>
+            <a:off x="4151376" y="2962656"/>
+            <a:ext cx="3867912" cy="612648"/>
+          </a:xfrm>
+          <a:prstGeom prst="rect">
+            <a:avLst/>
+          </a:prstGeom>
+          <a:noFill/>
+        </p:spPr>
+        <p:txBody>
+          <a:bodyPr wrap="square" lIns="0" rIns="0" tIns="0" bIns="0">
+            <a:spAutoFit/>
+          </a:bodyPr>
+          <a:lstStyle/>
+          <a:p>
+            <a:pPr>
               <a:spcAft>
-                <a:spcPts val="700"/>
+                <a:spcPts val="200"/>
               </a:spcAft>
-            </a:pPr>
-            <a:r>
-              <a:rPr sz="950">
-                <a:solidFill>
-                  <a:srgbClr val="232323"/>
-                </a:solidFill>
-                <a:latin typeface="Arial"/>
-              </a:rPr>
-              <a:t>• </a:t>
-            </a:r>
-            <a:r>
-              <a:rPr sz="950" b="1">
-                <a:solidFill>
-                  <a:srgbClr val="000000"/>
-                </a:solidFill>
-                <a:latin typeface="Arial"/>
-              </a:rPr>
-              <a:t>India's first sub-pixel pyrometry platform</a:t>
-            </a:r>
-            <a:r>
-              <a:rPr sz="950">
-                <a:solidFill>
-                  <a:srgbClr val="232323"/>
-                </a:solidFill>
-                <a:latin typeface="Arial"/>
-              </a:rPr>
-              <a:t> to detect industrial fires.</a:t>
+              <a:defRPr sz="750">
+                <a:solidFill>
+                  <a:srgbClr val="334155"/>
+                </a:solidFill>
+                <a:latin typeface="Arial"/>
+              </a:defRPr>
+            </a:pPr>
+            <a:r>
+              <a:t>• Dual-Band Inversion: Solves flame temp (Tf &gt; 1100 K) &amp; burning area (Af).</a:t>
             </a:r>
           </a:p>
           <a:p>
             <a:pPr>
-              <a:lnSpc>
-                <a:spcPct val="115000"/>
-              </a:lnSpc>
+              <a:defRPr sz="750">
+                <a:solidFill>
+                  <a:srgbClr val="334155"/>
+                </a:solidFill>
+                <a:latin typeface="Arial"/>
+              </a:defRPr>
+            </a:pPr>
+            <a:r>
+              <a:t>• Eliminates pixel-smearing: extracts pinpoint fires from cold background.</a:t>
+            </a:r>
+          </a:p>
+        </p:txBody>
+      </p:sp>
+      <p:sp>
+        <p:nvSpPr>
+          <p:cNvPr id="32" name="Down Arrow 31"/>
+          <p:cNvSpPr/>
+          <p:nvPr/>
+        </p:nvSpPr>
+        <p:spPr>
+          <a:xfrm>
+            <a:off x="5993892" y="3639312"/>
+            <a:ext cx="182880" cy="118872"/>
+          </a:xfrm>
+          <a:prstGeom prst="downArrow">
+            <a:avLst/>
+          </a:prstGeom>
+          <a:solidFill>
+            <a:srgbClr val="94A3B8"/>
+          </a:solidFill>
+          <a:ln>
+            <a:noFill/>
+          </a:ln>
+        </p:spPr>
+        <p:style>
+          <a:lnRef idx="1">
+            <a:schemeClr val="accent1"/>
+          </a:lnRef>
+          <a:fillRef idx="3">
+            <a:schemeClr val="accent1"/>
+          </a:fillRef>
+          <a:effectRef idx="2">
+            <a:schemeClr val="accent1"/>
+          </a:effectRef>
+          <a:fontRef idx="minor">
+            <a:schemeClr val="lt1"/>
+          </a:fontRef>
+        </p:style>
+        <p:txBody>
+          <a:bodyPr rtlCol="0" anchor="ctr"/>
+          <a:lstStyle/>
+          <a:p>
+            <a:pPr algn="ctr"/>
+          </a:p>
+        </p:txBody>
+      </p:sp>
+      <p:sp>
+        <p:nvSpPr>
+          <p:cNvPr id="33" name="Rounded Rectangle 32"/>
+          <p:cNvSpPr/>
+          <p:nvPr/>
+        </p:nvSpPr>
+        <p:spPr>
+          <a:xfrm>
+            <a:off x="4005072" y="3767328"/>
+            <a:ext cx="4160520" cy="1051560"/>
+          </a:xfrm>
+          <a:prstGeom prst="roundRect">
+            <a:avLst/>
+          </a:prstGeom>
+          <a:solidFill>
+            <a:srgbClr val="ECFDF5"/>
+          </a:solidFill>
+          <a:ln w="15240">
+            <a:solidFill>
+              <a:srgbClr val="A7F3D0"/>
+            </a:solidFill>
+          </a:ln>
+        </p:spPr>
+        <p:style>
+          <a:lnRef idx="1">
+            <a:schemeClr val="accent1"/>
+          </a:lnRef>
+          <a:fillRef idx="3">
+            <a:schemeClr val="accent1"/>
+          </a:fillRef>
+          <a:effectRef idx="2">
+            <a:schemeClr val="accent1"/>
+          </a:effectRef>
+          <a:fontRef idx="minor">
+            <a:schemeClr val="lt1"/>
+          </a:fontRef>
+        </p:style>
+        <p:txBody>
+          <a:bodyPr rtlCol="0" anchor="ctr"/>
+          <a:lstStyle/>
+          <a:p>
+            <a:pPr algn="ctr"/>
+          </a:p>
+        </p:txBody>
+      </p:sp>
+      <p:sp>
+        <p:nvSpPr>
+          <p:cNvPr id="34" name="Rounded Rectangle 33"/>
+          <p:cNvSpPr/>
+          <p:nvPr/>
+        </p:nvSpPr>
+        <p:spPr>
+          <a:xfrm>
+            <a:off x="4078224" y="3858768"/>
+            <a:ext cx="777240" cy="237744"/>
+          </a:xfrm>
+          <a:prstGeom prst="roundRect">
+            <a:avLst/>
+          </a:prstGeom>
+          <a:solidFill>
+            <a:srgbClr val="059669"/>
+          </a:solidFill>
+          <a:ln>
+            <a:noFill/>
+          </a:ln>
+        </p:spPr>
+        <p:style>
+          <a:lnRef idx="1">
+            <a:schemeClr val="accent1"/>
+          </a:lnRef>
+          <a:fillRef idx="3">
+            <a:schemeClr val="accent1"/>
+          </a:fillRef>
+          <a:effectRef idx="2">
+            <a:schemeClr val="accent1"/>
+          </a:effectRef>
+          <a:fontRef idx="minor">
+            <a:schemeClr val="lt1"/>
+          </a:fontRef>
+        </p:style>
+        <p:txBody>
+          <a:bodyPr rtlCol="0" anchor="ctr"/>
+          <a:lstStyle/>
+          <a:p>
+            <a:pPr algn="ctr">
+              <a:defRPr sz="750" b="1">
+                <a:solidFill>
+                  <a:srgbClr val="F8FAFC"/>
+                </a:solidFill>
+                <a:latin typeface="Arial"/>
+              </a:defRPr>
+            </a:pPr>
+            <a:r>
+              <a:t>LAYER 3</a:t>
+            </a:r>
+          </a:p>
+        </p:txBody>
+      </p:sp>
+      <p:sp>
+        <p:nvSpPr>
+          <p:cNvPr id="35" name="TextBox 34"/>
+          <p:cNvSpPr txBox="1"/>
+          <p:nvPr/>
+        </p:nvSpPr>
+        <p:spPr>
+          <a:xfrm>
+            <a:off x="4937760" y="3840480"/>
+            <a:ext cx="3136392" cy="274320"/>
+          </a:xfrm>
+          <a:prstGeom prst="rect">
+            <a:avLst/>
+          </a:prstGeom>
+          <a:noFill/>
+        </p:spPr>
+        <p:txBody>
+          <a:bodyPr wrap="none" lIns="0" rIns="0" tIns="0" bIns="0">
+            <a:spAutoFit/>
+          </a:bodyPr>
+          <a:lstStyle/>
+          <a:p>
+            <a:pPr>
+              <a:defRPr sz="900" b="1">
+                <a:solidFill>
+                  <a:srgbClr val="0F172A"/>
+                </a:solidFill>
+                <a:latin typeface="Arial"/>
+              </a:defRPr>
+            </a:pPr>
+            <a:r>
+              <a:t>2-Stage Hierarchical ML + 10m Ground Truth</a:t>
+            </a:r>
+          </a:p>
+        </p:txBody>
+      </p:sp>
+      <p:sp>
+        <p:nvSpPr>
+          <p:cNvPr id="36" name="TextBox 35"/>
+          <p:cNvSpPr txBox="1"/>
+          <p:nvPr/>
+        </p:nvSpPr>
+        <p:spPr>
+          <a:xfrm>
+            <a:off x="4151376" y="4151376"/>
+            <a:ext cx="3867912" cy="612648"/>
+          </a:xfrm>
+          <a:prstGeom prst="rect">
+            <a:avLst/>
+          </a:prstGeom>
+          <a:noFill/>
+        </p:spPr>
+        <p:txBody>
+          <a:bodyPr wrap="square" lIns="0" rIns="0" tIns="0" bIns="0">
+            <a:spAutoFit/>
+          </a:bodyPr>
+          <a:lstStyle/>
+          <a:p>
+            <a:pPr>
               <a:spcAft>
-                <a:spcPts val="700"/>
+                <a:spcPts val="200"/>
               </a:spcAft>
-            </a:pPr>
-            <a:r>
-              <a:rPr sz="950">
-                <a:solidFill>
-                  <a:srgbClr val="232323"/>
-                </a:solidFill>
-                <a:latin typeface="Arial"/>
-              </a:rPr>
-              <a:t>• </a:t>
-            </a:r>
-            <a:r>
-              <a:rPr sz="950" b="1">
-                <a:solidFill>
-                  <a:srgbClr val="000000"/>
-                </a:solidFill>
-                <a:latin typeface="Arial"/>
-              </a:rPr>
-              <a:t>Converts raw heat pixels into physical flame data</a:t>
-            </a:r>
-            <a:r>
-              <a:rPr sz="950">
-                <a:solidFill>
-                  <a:srgbClr val="232323"/>
-                </a:solidFill>
-                <a:latin typeface="Arial"/>
-              </a:rPr>
-              <a:t> (temperature &amp; burning area) with zero AI hallucination.</a:t>
+              <a:defRPr sz="750">
+                <a:solidFill>
+                  <a:srgbClr val="334155"/>
+                </a:solidFill>
+                <a:latin typeface="Arial"/>
+              </a:defRPr>
+            </a:pPr>
+            <a:r>
+              <a:t>• TreeSHAP-verified AI segregates permitted flaring vs explosions.</a:t>
             </a:r>
           </a:p>
           <a:p>
             <a:pPr>
-              <a:lnSpc>
-                <a:spcPct val="115000"/>
-              </a:lnSpc>
+              <a:defRPr sz="750">
+                <a:solidFill>
+                  <a:srgbClr val="334155"/>
+                </a:solidFill>
+                <a:latin typeface="Arial"/>
+              </a:defRPr>
+            </a:pPr>
+            <a:r>
+              <a:t>• Sentinel-1/2 10m ESA WorldCover validates Built-up (Class 50) vs crops.</a:t>
+            </a:r>
+          </a:p>
+        </p:txBody>
+      </p:sp>
+      <p:sp>
+        <p:nvSpPr>
+          <p:cNvPr id="37" name="Down Arrow 36"/>
+          <p:cNvSpPr/>
+          <p:nvPr/>
+        </p:nvSpPr>
+        <p:spPr>
+          <a:xfrm>
+            <a:off x="5993892" y="4828032"/>
+            <a:ext cx="182880" cy="118872"/>
+          </a:xfrm>
+          <a:prstGeom prst="downArrow">
+            <a:avLst/>
+          </a:prstGeom>
+          <a:solidFill>
+            <a:srgbClr val="94A3B8"/>
+          </a:solidFill>
+          <a:ln>
+            <a:noFill/>
+          </a:ln>
+        </p:spPr>
+        <p:style>
+          <a:lnRef idx="1">
+            <a:schemeClr val="accent1"/>
+          </a:lnRef>
+          <a:fillRef idx="3">
+            <a:schemeClr val="accent1"/>
+          </a:fillRef>
+          <a:effectRef idx="2">
+            <a:schemeClr val="accent1"/>
+          </a:effectRef>
+          <a:fontRef idx="minor">
+            <a:schemeClr val="lt1"/>
+          </a:fontRef>
+        </p:style>
+        <p:txBody>
+          <a:bodyPr rtlCol="0" anchor="ctr"/>
+          <a:lstStyle/>
+          <a:p>
+            <a:pPr algn="ctr"/>
+          </a:p>
+        </p:txBody>
+      </p:sp>
+      <p:sp>
+        <p:nvSpPr>
+          <p:cNvPr id="38" name="Rounded Rectangle 37"/>
+          <p:cNvSpPr/>
+          <p:nvPr/>
+        </p:nvSpPr>
+        <p:spPr>
+          <a:xfrm>
+            <a:off x="4005072" y="4956048"/>
+            <a:ext cx="4160520" cy="1051560"/>
+          </a:xfrm>
+          <a:prstGeom prst="roundRect">
+            <a:avLst/>
+          </a:prstGeom>
+          <a:solidFill>
+            <a:srgbClr val="FFFBEB"/>
+          </a:solidFill>
+          <a:ln w="15240">
+            <a:solidFill>
+              <a:srgbClr val="FDE68A"/>
+            </a:solidFill>
+          </a:ln>
+        </p:spPr>
+        <p:style>
+          <a:lnRef idx="1">
+            <a:schemeClr val="accent1"/>
+          </a:lnRef>
+          <a:fillRef idx="3">
+            <a:schemeClr val="accent1"/>
+          </a:fillRef>
+          <a:effectRef idx="2">
+            <a:schemeClr val="accent1"/>
+          </a:effectRef>
+          <a:fontRef idx="minor">
+            <a:schemeClr val="lt1"/>
+          </a:fontRef>
+        </p:style>
+        <p:txBody>
+          <a:bodyPr rtlCol="0" anchor="ctr"/>
+          <a:lstStyle/>
+          <a:p>
+            <a:pPr algn="ctr"/>
+          </a:p>
+        </p:txBody>
+      </p:sp>
+      <p:sp>
+        <p:nvSpPr>
+          <p:cNvPr id="39" name="Rounded Rectangle 38"/>
+          <p:cNvSpPr/>
+          <p:nvPr/>
+        </p:nvSpPr>
+        <p:spPr>
+          <a:xfrm>
+            <a:off x="4078224" y="5047488"/>
+            <a:ext cx="777240" cy="237744"/>
+          </a:xfrm>
+          <a:prstGeom prst="roundRect">
+            <a:avLst/>
+          </a:prstGeom>
+          <a:solidFill>
+            <a:srgbClr val="D97706"/>
+          </a:solidFill>
+          <a:ln>
+            <a:noFill/>
+          </a:ln>
+        </p:spPr>
+        <p:style>
+          <a:lnRef idx="1">
+            <a:schemeClr val="accent1"/>
+          </a:lnRef>
+          <a:fillRef idx="3">
+            <a:schemeClr val="accent1"/>
+          </a:fillRef>
+          <a:effectRef idx="2">
+            <a:schemeClr val="accent1"/>
+          </a:effectRef>
+          <a:fontRef idx="minor">
+            <a:schemeClr val="lt1"/>
+          </a:fontRef>
+        </p:style>
+        <p:txBody>
+          <a:bodyPr rtlCol="0" anchor="ctr"/>
+          <a:lstStyle/>
+          <a:p>
+            <a:pPr algn="ctr">
+              <a:defRPr sz="750" b="1">
+                <a:solidFill>
+                  <a:srgbClr val="F8FAFC"/>
+                </a:solidFill>
+                <a:latin typeface="Arial"/>
+              </a:defRPr>
+            </a:pPr>
+            <a:r>
+              <a:t>LAYER 4</a:t>
+            </a:r>
+          </a:p>
+        </p:txBody>
+      </p:sp>
+      <p:sp>
+        <p:nvSpPr>
+          <p:cNvPr id="40" name="TextBox 39"/>
+          <p:cNvSpPr txBox="1"/>
+          <p:nvPr/>
+        </p:nvSpPr>
+        <p:spPr>
+          <a:xfrm>
+            <a:off x="4937760" y="5029200"/>
+            <a:ext cx="3136392" cy="274320"/>
+          </a:xfrm>
+          <a:prstGeom prst="rect">
+            <a:avLst/>
+          </a:prstGeom>
+          <a:noFill/>
+        </p:spPr>
+        <p:txBody>
+          <a:bodyPr wrap="none" lIns="0" rIns="0" tIns="0" bIns="0">
+            <a:spAutoFit/>
+          </a:bodyPr>
+          <a:lstStyle/>
+          <a:p>
+            <a:pPr>
+              <a:defRPr sz="900" b="1">
+                <a:solidFill>
+                  <a:srgbClr val="0F172A"/>
+                </a:solidFill>
+                <a:latin typeface="Arial"/>
+              </a:defRPr>
+            </a:pPr>
+            <a:r>
+              <a:t>Atmospheric Plume &amp; NDRF Tactical Dispatch</a:t>
+            </a:r>
+          </a:p>
+        </p:txBody>
+      </p:sp>
+      <p:sp>
+        <p:nvSpPr>
+          <p:cNvPr id="41" name="TextBox 40"/>
+          <p:cNvSpPr txBox="1"/>
+          <p:nvPr/>
+        </p:nvSpPr>
+        <p:spPr>
+          <a:xfrm>
+            <a:off x="4151376" y="5340096"/>
+            <a:ext cx="3867912" cy="612648"/>
+          </a:xfrm>
+          <a:prstGeom prst="rect">
+            <a:avLst/>
+          </a:prstGeom>
+          <a:noFill/>
+        </p:spPr>
+        <p:txBody>
+          <a:bodyPr wrap="square" lIns="0" rIns="0" tIns="0" bIns="0">
+            <a:spAutoFit/>
+          </a:bodyPr>
+          <a:lstStyle/>
+          <a:p>
+            <a:pPr>
               <a:spcAft>
-                <a:spcPts val="700"/>
+                <a:spcPts val="200"/>
               </a:spcAft>
-            </a:pPr>
-            <a:r>
-              <a:rPr sz="950">
-                <a:solidFill>
-                  <a:srgbClr val="232323"/>
-                </a:solidFill>
-                <a:latin typeface="Arial"/>
-              </a:rPr>
-              <a:t>• </a:t>
-            </a:r>
-            <a:r>
-              <a:rPr sz="950" b="1">
-                <a:solidFill>
-                  <a:srgbClr val="000000"/>
-                </a:solidFill>
-                <a:latin typeface="Arial"/>
-              </a:rPr>
-              <a:t>Dual-satellite land grounding</a:t>
-            </a:r>
-            <a:r>
-              <a:rPr sz="950">
-                <a:solidFill>
-                  <a:srgbClr val="232323"/>
-                </a:solidFill>
-                <a:latin typeface="Arial"/>
-              </a:rPr>
-              <a:t> uses 10m ESA land-cover and Sentinel-2 data to eliminate false alarms at industrial plants.</a:t>
+              <a:defRPr sz="750">
+                <a:solidFill>
+                  <a:srgbClr val="334155"/>
+                </a:solidFill>
+                <a:latin typeface="Arial"/>
+              </a:defRPr>
+            </a:pPr>
+            <a:r>
+              <a:t>• Briggs buoyant rise + Pasquill-Gifford Gaussian dispersion on live wind.</a:t>
             </a:r>
           </a:p>
           <a:p>
             <a:pPr>
-              <a:lnSpc>
-                <a:spcPct val="115000"/>
-              </a:lnSpc>
+              <a:defRPr sz="750">
+                <a:solidFill>
+                  <a:srgbClr val="334155"/>
+                </a:solidFill>
+                <a:latin typeface="Arial"/>
+              </a:defRPr>
+            </a:pPr>
+            <a:r>
+              <a:t>• Instant Incident Action Plan (IAP) with automated WhatsApp/SMS dispatch.</a:t>
+            </a:r>
+          </a:p>
+        </p:txBody>
+      </p:sp>
+      <p:sp>
+        <p:nvSpPr>
+          <p:cNvPr id="42" name="TextBox 41"/>
+          <p:cNvSpPr txBox="1"/>
+          <p:nvPr/>
+        </p:nvSpPr>
+        <p:spPr>
+          <a:xfrm>
+            <a:off x="8348472" y="1115568"/>
+            <a:ext cx="3474720" cy="256032"/>
+          </a:xfrm>
+          <a:prstGeom prst="rect">
+            <a:avLst/>
+          </a:prstGeom>
+          <a:noFill/>
+        </p:spPr>
+        <p:txBody>
+          <a:bodyPr wrap="none" lIns="0" rIns="0" tIns="0" bIns="0">
+            <a:spAutoFit/>
+          </a:bodyPr>
+          <a:lstStyle/>
+          <a:p>
+            <a:pPr algn="ctr">
+              <a:defRPr sz="900" b="1">
+                <a:solidFill>
+                  <a:srgbClr val="991B1B"/>
+                </a:solidFill>
+                <a:latin typeface="Arial"/>
+              </a:defRPr>
+            </a:pPr>
+            <a:r>
+              <a:t>CRITICAL RISK   vs   PYROSAT SOLUTION</a:t>
+            </a:r>
+          </a:p>
+        </p:txBody>
+      </p:sp>
+      <p:sp>
+        <p:nvSpPr>
+          <p:cNvPr id="43" name="Rounded Rectangle 42"/>
+          <p:cNvSpPr/>
+          <p:nvPr/>
+        </p:nvSpPr>
+        <p:spPr>
+          <a:xfrm>
+            <a:off x="8348472" y="1389888"/>
+            <a:ext cx="1572768" cy="621792"/>
+          </a:xfrm>
+          <a:prstGeom prst="roundRect">
+            <a:avLst/>
+          </a:prstGeom>
+          <a:solidFill>
+            <a:srgbClr val="FEE2E2"/>
+          </a:solidFill>
+          <a:ln w="12700">
+            <a:solidFill>
+              <a:srgbClr val="EF4444"/>
+            </a:solidFill>
+          </a:ln>
+        </p:spPr>
+        <p:style>
+          <a:lnRef idx="1">
+            <a:schemeClr val="accent1"/>
+          </a:lnRef>
+          <a:fillRef idx="3">
+            <a:schemeClr val="accent1"/>
+          </a:fillRef>
+          <a:effectRef idx="2">
+            <a:schemeClr val="accent1"/>
+          </a:effectRef>
+          <a:fontRef idx="minor">
+            <a:schemeClr val="lt1"/>
+          </a:fontRef>
+        </p:style>
+        <p:txBody>
+          <a:bodyPr rtlCol="0" anchor="ctr" wrap="square" lIns="36576" rIns="36576" tIns="36576" bIns="36576"/>
+          <a:lstStyle/>
+          <a:p>
+            <a:pPr algn="ctr">
+              <a:defRPr sz="750" b="1">
+                <a:solidFill>
+                  <a:srgbClr val="B91C1C"/>
+                </a:solidFill>
+                <a:latin typeface="Arial"/>
+              </a:defRPr>
+            </a:pPr>
+            <a:r>
+              <a:t>🔴 Coarse 375m Satellite Pixels</a:t>
+            </a:r>
+          </a:p>
+        </p:txBody>
+      </p:sp>
+      <p:sp>
+        <p:nvSpPr>
+          <p:cNvPr id="44" name="TextBox 43"/>
+          <p:cNvSpPr txBox="1"/>
+          <p:nvPr/>
+        </p:nvSpPr>
+        <p:spPr>
+          <a:xfrm>
+            <a:off x="9921240" y="1536192"/>
+            <a:ext cx="329184" cy="329184"/>
+          </a:xfrm>
+          <a:prstGeom prst="rect">
+            <a:avLst/>
+          </a:prstGeom>
+          <a:noFill/>
+        </p:spPr>
+        <p:txBody>
+          <a:bodyPr wrap="none" lIns="0" rIns="0" tIns="0" bIns="0">
+            <a:spAutoFit/>
+          </a:bodyPr>
+          <a:lstStyle/>
+          <a:p>
+            <a:pPr algn="ctr">
+              <a:defRPr sz="1200" b="1">
+                <a:solidFill>
+                  <a:srgbClr val="64748B"/>
+                </a:solidFill>
+                <a:latin typeface="Arial"/>
+              </a:defRPr>
+            </a:pPr>
+            <a:r>
+              <a:t>⇄</a:t>
+            </a:r>
+          </a:p>
+        </p:txBody>
+      </p:sp>
+      <p:sp>
+        <p:nvSpPr>
+          <p:cNvPr id="45" name="Rounded Rectangle 44"/>
+          <p:cNvSpPr/>
+          <p:nvPr/>
+        </p:nvSpPr>
+        <p:spPr>
+          <a:xfrm>
+            <a:off x="10250424" y="1389888"/>
+            <a:ext cx="1572768" cy="621792"/>
+          </a:xfrm>
+          <a:prstGeom prst="roundRect">
+            <a:avLst/>
+          </a:prstGeom>
+          <a:solidFill>
+            <a:srgbClr val="DCFCE7"/>
+          </a:solidFill>
+          <a:ln w="12700">
+            <a:solidFill>
+              <a:srgbClr val="22C55E"/>
+            </a:solidFill>
+          </a:ln>
+        </p:spPr>
+        <p:style>
+          <a:lnRef idx="1">
+            <a:schemeClr val="accent1"/>
+          </a:lnRef>
+          <a:fillRef idx="3">
+            <a:schemeClr val="accent1"/>
+          </a:fillRef>
+          <a:effectRef idx="2">
+            <a:schemeClr val="accent1"/>
+          </a:effectRef>
+          <a:fontRef idx="minor">
+            <a:schemeClr val="lt1"/>
+          </a:fontRef>
+        </p:style>
+        <p:txBody>
+          <a:bodyPr rtlCol="0" anchor="ctr" wrap="square" lIns="36576" rIns="36576" tIns="36576" bIns="36576"/>
+          <a:lstStyle/>
+          <a:p>
+            <a:pPr algn="ctr">
+              <a:defRPr sz="750" b="1">
+                <a:solidFill>
+                  <a:srgbClr val="15803D"/>
+                </a:solidFill>
+                <a:latin typeface="Arial"/>
+              </a:defRPr>
+            </a:pPr>
+            <a:r>
+              <a:t>🟢 Sub-Pixel Planck Pyrometry (Tf, Af)</a:t>
+            </a:r>
+          </a:p>
+        </p:txBody>
+      </p:sp>
+      <p:sp>
+        <p:nvSpPr>
+          <p:cNvPr id="46" name="Rounded Rectangle 45"/>
+          <p:cNvSpPr/>
+          <p:nvPr/>
+        </p:nvSpPr>
+        <p:spPr>
+          <a:xfrm>
+            <a:off x="8348472" y="2121408"/>
+            <a:ext cx="1572768" cy="621792"/>
+          </a:xfrm>
+          <a:prstGeom prst="roundRect">
+            <a:avLst/>
+          </a:prstGeom>
+          <a:solidFill>
+            <a:srgbClr val="FEE2E2"/>
+          </a:solidFill>
+          <a:ln w="12700">
+            <a:solidFill>
+              <a:srgbClr val="EF4444"/>
+            </a:solidFill>
+          </a:ln>
+        </p:spPr>
+        <p:style>
+          <a:lnRef idx="1">
+            <a:schemeClr val="accent1"/>
+          </a:lnRef>
+          <a:fillRef idx="3">
+            <a:schemeClr val="accent1"/>
+          </a:fillRef>
+          <a:effectRef idx="2">
+            <a:schemeClr val="accent1"/>
+          </a:effectRef>
+          <a:fontRef idx="minor">
+            <a:schemeClr val="lt1"/>
+          </a:fontRef>
+        </p:style>
+        <p:txBody>
+          <a:bodyPr rtlCol="0" anchor="ctr" wrap="square" lIns="36576" rIns="36576" tIns="36576" bIns="36576"/>
+          <a:lstStyle/>
+          <a:p>
+            <a:pPr algn="ctr">
+              <a:defRPr sz="750" b="1">
+                <a:solidFill>
+                  <a:srgbClr val="B91C1C"/>
+                </a:solidFill>
+                <a:latin typeface="Arial"/>
+              </a:defRPr>
+            </a:pPr>
+            <a:r>
+              <a:t>🔴 Routine Flares Mistaken as Fires</a:t>
+            </a:r>
+          </a:p>
+        </p:txBody>
+      </p:sp>
+      <p:sp>
+        <p:nvSpPr>
+          <p:cNvPr id="47" name="TextBox 46"/>
+          <p:cNvSpPr txBox="1"/>
+          <p:nvPr/>
+        </p:nvSpPr>
+        <p:spPr>
+          <a:xfrm>
+            <a:off x="9921240" y="2267712"/>
+            <a:ext cx="329184" cy="329184"/>
+          </a:xfrm>
+          <a:prstGeom prst="rect">
+            <a:avLst/>
+          </a:prstGeom>
+          <a:noFill/>
+        </p:spPr>
+        <p:txBody>
+          <a:bodyPr wrap="none" lIns="0" rIns="0" tIns="0" bIns="0">
+            <a:spAutoFit/>
+          </a:bodyPr>
+          <a:lstStyle/>
+          <a:p>
+            <a:pPr algn="ctr">
+              <a:defRPr sz="1200" b="1">
+                <a:solidFill>
+                  <a:srgbClr val="64748B"/>
+                </a:solidFill>
+                <a:latin typeface="Arial"/>
+              </a:defRPr>
+            </a:pPr>
+            <a:r>
+              <a:t>⇄</a:t>
+            </a:r>
+          </a:p>
+        </p:txBody>
+      </p:sp>
+      <p:sp>
+        <p:nvSpPr>
+          <p:cNvPr id="48" name="Rounded Rectangle 47"/>
+          <p:cNvSpPr/>
+          <p:nvPr/>
+        </p:nvSpPr>
+        <p:spPr>
+          <a:xfrm>
+            <a:off x="10250424" y="2121408"/>
+            <a:ext cx="1572768" cy="621792"/>
+          </a:xfrm>
+          <a:prstGeom prst="roundRect">
+            <a:avLst/>
+          </a:prstGeom>
+          <a:solidFill>
+            <a:srgbClr val="DCFCE7"/>
+          </a:solidFill>
+          <a:ln w="12700">
+            <a:solidFill>
+              <a:srgbClr val="22C55E"/>
+            </a:solidFill>
+          </a:ln>
+        </p:spPr>
+        <p:style>
+          <a:lnRef idx="1">
+            <a:schemeClr val="accent1"/>
+          </a:lnRef>
+          <a:fillRef idx="3">
+            <a:schemeClr val="accent1"/>
+          </a:fillRef>
+          <a:effectRef idx="2">
+            <a:schemeClr val="accent1"/>
+          </a:effectRef>
+          <a:fontRef idx="minor">
+            <a:schemeClr val="lt1"/>
+          </a:fontRef>
+        </p:style>
+        <p:txBody>
+          <a:bodyPr rtlCol="0" anchor="ctr" wrap="square" lIns="36576" rIns="36576" tIns="36576" bIns="36576"/>
+          <a:lstStyle/>
+          <a:p>
+            <a:pPr algn="ctr">
+              <a:defRPr sz="750" b="1">
+                <a:solidFill>
+                  <a:srgbClr val="15803D"/>
+                </a:solidFill>
+                <a:latin typeface="Arial"/>
+              </a:defRPr>
+            </a:pPr>
+            <a:r>
+              <a:t>🟢 2-Stage Hierarchical ML Shield</a:t>
+            </a:r>
+          </a:p>
+        </p:txBody>
+      </p:sp>
+      <p:sp>
+        <p:nvSpPr>
+          <p:cNvPr id="49" name="Rounded Rectangle 48"/>
+          <p:cNvSpPr/>
+          <p:nvPr/>
+        </p:nvSpPr>
+        <p:spPr>
+          <a:xfrm>
+            <a:off x="8348472" y="2852928"/>
+            <a:ext cx="1572768" cy="621792"/>
+          </a:xfrm>
+          <a:prstGeom prst="roundRect">
+            <a:avLst/>
+          </a:prstGeom>
+          <a:solidFill>
+            <a:srgbClr val="FEE2E2"/>
+          </a:solidFill>
+          <a:ln w="12700">
+            <a:solidFill>
+              <a:srgbClr val="EF4444"/>
+            </a:solidFill>
+          </a:ln>
+        </p:spPr>
+        <p:style>
+          <a:lnRef idx="1">
+            <a:schemeClr val="accent1"/>
+          </a:lnRef>
+          <a:fillRef idx="3">
+            <a:schemeClr val="accent1"/>
+          </a:fillRef>
+          <a:effectRef idx="2">
+            <a:schemeClr val="accent1"/>
+          </a:effectRef>
+          <a:fontRef idx="minor">
+            <a:schemeClr val="lt1"/>
+          </a:fontRef>
+        </p:style>
+        <p:txBody>
+          <a:bodyPr rtlCol="0" anchor="ctr" wrap="square" lIns="36576" rIns="36576" tIns="36576" bIns="36576"/>
+          <a:lstStyle/>
+          <a:p>
+            <a:pPr algn="ctr">
+              <a:defRPr sz="750" b="1">
+                <a:solidFill>
+                  <a:srgbClr val="B91C1C"/>
+                </a:solidFill>
+                <a:latin typeface="Arial"/>
+              </a:defRPr>
+            </a:pPr>
+            <a:r>
+              <a:t>🔴 Blind Toxic Gas Cloud Inhalation</a:t>
+            </a:r>
+          </a:p>
+        </p:txBody>
+      </p:sp>
+      <p:sp>
+        <p:nvSpPr>
+          <p:cNvPr id="50" name="TextBox 49"/>
+          <p:cNvSpPr txBox="1"/>
+          <p:nvPr/>
+        </p:nvSpPr>
+        <p:spPr>
+          <a:xfrm>
+            <a:off x="9921240" y="2999232"/>
+            <a:ext cx="329184" cy="329184"/>
+          </a:xfrm>
+          <a:prstGeom prst="rect">
+            <a:avLst/>
+          </a:prstGeom>
+          <a:noFill/>
+        </p:spPr>
+        <p:txBody>
+          <a:bodyPr wrap="none" lIns="0" rIns="0" tIns="0" bIns="0">
+            <a:spAutoFit/>
+          </a:bodyPr>
+          <a:lstStyle/>
+          <a:p>
+            <a:pPr algn="ctr">
+              <a:defRPr sz="1200" b="1">
+                <a:solidFill>
+                  <a:srgbClr val="64748B"/>
+                </a:solidFill>
+                <a:latin typeface="Arial"/>
+              </a:defRPr>
+            </a:pPr>
+            <a:r>
+              <a:t>⇄</a:t>
+            </a:r>
+          </a:p>
+        </p:txBody>
+      </p:sp>
+      <p:sp>
+        <p:nvSpPr>
+          <p:cNvPr id="51" name="Rounded Rectangle 50"/>
+          <p:cNvSpPr/>
+          <p:nvPr/>
+        </p:nvSpPr>
+        <p:spPr>
+          <a:xfrm>
+            <a:off x="10250424" y="2852928"/>
+            <a:ext cx="1572768" cy="621792"/>
+          </a:xfrm>
+          <a:prstGeom prst="roundRect">
+            <a:avLst/>
+          </a:prstGeom>
+          <a:solidFill>
+            <a:srgbClr val="DCFCE7"/>
+          </a:solidFill>
+          <a:ln w="12700">
+            <a:solidFill>
+              <a:srgbClr val="22C55E"/>
+            </a:solidFill>
+          </a:ln>
+        </p:spPr>
+        <p:style>
+          <a:lnRef idx="1">
+            <a:schemeClr val="accent1"/>
+          </a:lnRef>
+          <a:fillRef idx="3">
+            <a:schemeClr val="accent1"/>
+          </a:fillRef>
+          <a:effectRef idx="2">
+            <a:schemeClr val="accent1"/>
+          </a:effectRef>
+          <a:fontRef idx="minor">
+            <a:schemeClr val="lt1"/>
+          </a:fontRef>
+        </p:style>
+        <p:txBody>
+          <a:bodyPr rtlCol="0" anchor="ctr" wrap="square" lIns="36576" rIns="36576" tIns="36576" bIns="36576"/>
+          <a:lstStyle/>
+          <a:p>
+            <a:pPr algn="ctr">
+              <a:defRPr sz="750" b="1">
+                <a:solidFill>
+                  <a:srgbClr val="15803D"/>
+                </a:solidFill>
+                <a:latin typeface="Arial"/>
+              </a:defRPr>
+            </a:pPr>
+            <a:r>
+              <a:t>🟢 3D Gaussian Plume Standoff Rings</a:t>
+            </a:r>
+          </a:p>
+        </p:txBody>
+      </p:sp>
+      <p:sp>
+        <p:nvSpPr>
+          <p:cNvPr id="52" name="Rounded Rectangle 51"/>
+          <p:cNvSpPr/>
+          <p:nvPr/>
+        </p:nvSpPr>
+        <p:spPr>
+          <a:xfrm>
+            <a:off x="8348472" y="3584448"/>
+            <a:ext cx="1572768" cy="621792"/>
+          </a:xfrm>
+          <a:prstGeom prst="roundRect">
+            <a:avLst/>
+          </a:prstGeom>
+          <a:solidFill>
+            <a:srgbClr val="FEE2E2"/>
+          </a:solidFill>
+          <a:ln w="12700">
+            <a:solidFill>
+              <a:srgbClr val="EF4444"/>
+            </a:solidFill>
+          </a:ln>
+        </p:spPr>
+        <p:style>
+          <a:lnRef idx="1">
+            <a:schemeClr val="accent1"/>
+          </a:lnRef>
+          <a:fillRef idx="3">
+            <a:schemeClr val="accent1"/>
+          </a:fillRef>
+          <a:effectRef idx="2">
+            <a:schemeClr val="accent1"/>
+          </a:effectRef>
+          <a:fontRef idx="minor">
+            <a:schemeClr val="lt1"/>
+          </a:fontRef>
+        </p:style>
+        <p:txBody>
+          <a:bodyPr rtlCol="0" anchor="ctr" wrap="square" lIns="36576" rIns="36576" tIns="36576" bIns="36576"/>
+          <a:lstStyle/>
+          <a:p>
+            <a:pPr algn="ctr">
+              <a:defRPr sz="750" b="1">
+                <a:solidFill>
+                  <a:srgbClr val="B91C1C"/>
+                </a:solidFill>
+                <a:latin typeface="Arial"/>
+              </a:defRPr>
+            </a:pPr>
+            <a:r>
+              <a:t>🔴 Delayed Multi-Agency Dispatch</a:t>
+            </a:r>
+          </a:p>
+        </p:txBody>
+      </p:sp>
+      <p:sp>
+        <p:nvSpPr>
+          <p:cNvPr id="53" name="TextBox 52"/>
+          <p:cNvSpPr txBox="1"/>
+          <p:nvPr/>
+        </p:nvSpPr>
+        <p:spPr>
+          <a:xfrm>
+            <a:off x="9921240" y="3730752"/>
+            <a:ext cx="329184" cy="329184"/>
+          </a:xfrm>
+          <a:prstGeom prst="rect">
+            <a:avLst/>
+          </a:prstGeom>
+          <a:noFill/>
+        </p:spPr>
+        <p:txBody>
+          <a:bodyPr wrap="none" lIns="0" rIns="0" tIns="0" bIns="0">
+            <a:spAutoFit/>
+          </a:bodyPr>
+          <a:lstStyle/>
+          <a:p>
+            <a:pPr algn="ctr">
+              <a:defRPr sz="1200" b="1">
+                <a:solidFill>
+                  <a:srgbClr val="64748B"/>
+                </a:solidFill>
+                <a:latin typeface="Arial"/>
+              </a:defRPr>
+            </a:pPr>
+            <a:r>
+              <a:t>⇄</a:t>
+            </a:r>
+          </a:p>
+        </p:txBody>
+      </p:sp>
+      <p:sp>
+        <p:nvSpPr>
+          <p:cNvPr id="54" name="Rounded Rectangle 53"/>
+          <p:cNvSpPr/>
+          <p:nvPr/>
+        </p:nvSpPr>
+        <p:spPr>
+          <a:xfrm>
+            <a:off x="10250424" y="3584448"/>
+            <a:ext cx="1572768" cy="621792"/>
+          </a:xfrm>
+          <a:prstGeom prst="roundRect">
+            <a:avLst/>
+          </a:prstGeom>
+          <a:solidFill>
+            <a:srgbClr val="DCFCE7"/>
+          </a:solidFill>
+          <a:ln w="12700">
+            <a:solidFill>
+              <a:srgbClr val="22C55E"/>
+            </a:solidFill>
+          </a:ln>
+        </p:spPr>
+        <p:style>
+          <a:lnRef idx="1">
+            <a:schemeClr val="accent1"/>
+          </a:lnRef>
+          <a:fillRef idx="3">
+            <a:schemeClr val="accent1"/>
+          </a:fillRef>
+          <a:effectRef idx="2">
+            <a:schemeClr val="accent1"/>
+          </a:effectRef>
+          <a:fontRef idx="minor">
+            <a:schemeClr val="lt1"/>
+          </a:fontRef>
+        </p:style>
+        <p:txBody>
+          <a:bodyPr rtlCol="0" anchor="ctr" wrap="square" lIns="36576" rIns="36576" tIns="36576" bIns="36576"/>
+          <a:lstStyle/>
+          <a:p>
+            <a:pPr algn="ctr">
+              <a:defRPr sz="750" b="1">
+                <a:solidFill>
+                  <a:srgbClr val="15803D"/>
+                </a:solidFill>
+                <a:latin typeface="Arial"/>
+              </a:defRPr>
+            </a:pPr>
+            <a:r>
+              <a:t>🟢 1-Click Automated NDRF Action Plan</a:t>
+            </a:r>
+          </a:p>
+        </p:txBody>
+      </p:sp>
+      <p:pic>
+        <p:nvPicPr>
+          <p:cNvPr id="55" name="Picture 54" descr="image.jpg"/>
+          <p:cNvPicPr>
+            <a:picLocks noChangeAspect="1"/>
+          </p:cNvPicPr>
+          <p:nvPr/>
+        </p:nvPicPr>
+        <p:blipFill>
+          <a:blip r:embed="rId5"/>
+          <a:stretch>
+            <a:fillRect/>
+          </a:stretch>
+        </p:blipFill>
+        <p:spPr>
+          <a:xfrm>
+            <a:off x="8348472" y="4352544"/>
+            <a:ext cx="1554480" cy="1691640"/>
+          </a:xfrm>
+          <a:prstGeom prst="rect">
+            <a:avLst/>
+          </a:prstGeom>
+        </p:spPr>
+      </p:pic>
+      <p:sp>
+        <p:nvSpPr>
+          <p:cNvPr id="56" name="TextBox 55"/>
+          <p:cNvSpPr txBox="1"/>
+          <p:nvPr/>
+        </p:nvSpPr>
+        <p:spPr>
+          <a:xfrm>
+            <a:off x="9994392" y="4352544"/>
+            <a:ext cx="1828800" cy="1783080"/>
+          </a:xfrm>
+          <a:prstGeom prst="rect">
+            <a:avLst/>
+          </a:prstGeom>
+          <a:noFill/>
+        </p:spPr>
+        <p:txBody>
+          <a:bodyPr wrap="square" lIns="0" rIns="0" tIns="0" bIns="0">
+            <a:spAutoFit/>
+          </a:bodyPr>
+          <a:lstStyle/>
+          <a:p>
+            <a:pPr>
               <a:spcAft>
-                <a:spcPts val="700"/>
+                <a:spcPts val="200"/>
               </a:spcAft>
-            </a:pPr>
-            <a:r>
-              <a:rPr sz="950">
-                <a:solidFill>
-                  <a:srgbClr val="232323"/>
-                </a:solidFill>
-                <a:latin typeface="Arial"/>
-              </a:rPr>
-              <a:t>• </a:t>
-            </a:r>
-            <a:r>
-              <a:rPr sz="950" b="1">
-                <a:solidFill>
-                  <a:srgbClr val="000000"/>
-                </a:solidFill>
-                <a:latin typeface="Arial"/>
-              </a:rPr>
-              <a:t>Live Toxic Plume Dispersion Engine</a:t>
-            </a:r>
-            <a:r>
-              <a:rPr sz="950">
-                <a:solidFill>
-                  <a:srgbClr val="232323"/>
-                </a:solidFill>
-                <a:latin typeface="Arial"/>
-              </a:rPr>
-              <a:t> combines real-time wind and chemical data to map evacuation zones for first responders.</a:t>
+              <a:defRPr sz="850" b="1">
+                <a:solidFill>
+                  <a:srgbClr val="0F172A"/>
+                </a:solidFill>
+                <a:latin typeface="Arial"/>
+              </a:defRPr>
+            </a:pPr>
+            <a:r>
+              <a:t>Tactical Validation:</a:t>
+            </a:r>
+          </a:p>
+          <a:p>
+            <a:pPr>
+              <a:defRPr sz="720">
+                <a:solidFill>
+                  <a:srgbClr val="334155"/>
+                </a:solidFill>
+                <a:latin typeface="Arial"/>
+              </a:defRPr>
+            </a:pPr>
+            <a:r>
+              <a:t>Real-time 3D Gaussian toxic plume calculated using live Open-Meteo wind vectors with automated ERPG/IDLH evacuation rings.</a:t>
             </a:r>
           </a:p>
         </p:txBody>

</xml_diff>